<commit_message>
docs(business): add competitive analysis + sharpen pitch deck slide 09
competitive-analysis.md:
- 7 competitors mapped: ChatGPT, Ruangguru/Zenius, Coursera/Udemy,
  Khanmigo, LinkedIn Learning, Duolingo, Cakap
- Feature comparison matrix (10 capabilities)
- Positioning map: High Adaptivity x Bahasa Indonesia (unclaimed quadrant)
- 5 differentiation opportunities with research backing
- 4 competitive threats with response strategy
- Recommendations: double down / close gap / ignore

Pitch deck slide 09 (Impact/Value):
- Competitive box sharpened with stronger vs-competitor framing
- Added: 'Kuadran yang tidak ada pesaingnya: High Adaptivity x Bahasa Indonesia'
</commit_message>
<xml_diff>
--- a/slides/serambi-pitch-deck.pptx
+++ b/slides/serambi-pitch-deck.pptx
@@ -4165,7 +4165,7 @@
 </file>
 
 <file path=ppt/slides/slide9.xml><?xml version="1.0" encoding="utf-8"?>
-<p:sld xmlns:p="http://schemas.openxmlformats.org/presentationml/2006/main">
+<p:sld xmlns:a="http://schemas.openxmlformats.org/drawingml/2006/main" xmlns:p="http://schemas.openxmlformats.org/presentationml/2006/main">
   <p:cSld>
     <p:bg>
       <p:bgPr>
@@ -4428,52 +4428,88 @@
         <p:txBody>
           <a:bodyPr xmlns:a="http://schemas.openxmlformats.org/drawingml/2006/main"/>
           <a:lstStyle xmlns:a="http://schemas.openxmlformats.org/drawingml/2006/main"/>
-          <a:p xmlns:a="http://schemas.openxmlformats.org/drawingml/2006/main">
-            <a:r>
-              <a:rPr lang="en-US" sz="1600">
+          <a:p>
+            <a:r>
+              <a:rPr lang="en-US" sz="1500">
                 <a:solidFill>
                   <a:srgbClr val="A8C8FF"/>
                 </a:solidFill>
                 <a:latin typeface="Calibri"/>
                 <a:ea typeface="Calibri"/>
               </a:rPr>
-              <a:t>vs Kursus online (Ruangguru, Coursera): roadmap personal vs kurikulum tetap</a:t>
-            </a:r>
-          </a:p>
-          <a:p xmlns:a="http://schemas.openxmlformats.org/drawingml/2006/main">
-            <a:r>
-              <a:rPr lang="en-US" sz="1600">
+              <a:t>Mengapa bukan yang lain?</a:t>
+            </a:r>
+          </a:p>
+          <a:p>
+            <a:r>
+              <a:rPr lang="en-US" sz="1500">
                 <a:solidFill>
                   <a:srgbClr val="A8C8FF"/>
                 </a:solidFill>
                 <a:latin typeface="Calibri"/>
                 <a:ea typeface="Calibri"/>
               </a:rPr>
-              <a:t>vs ChatGPT: scaffold + guardrail vs oracle langsung jawab</a:t>
-            </a:r>
-          </a:p>
-          <a:p xmlns:a="http://schemas.openxmlformats.org/drawingml/2006/main">
-            <a:r>
-              <a:rPr lang="en-US" sz="1600">
+              <a:t>vs ChatGPT: oracle langsung jawab vs scaffold + guardrail anti-cognitive-offloading (BJET 694x)</a:t>
+            </a:r>
+          </a:p>
+          <a:p>
+            <a:r>
+              <a:rPr lang="en-US" sz="1500">
                 <a:solidFill>
                   <a:srgbClr val="A8C8FF"/>
                 </a:solidFill>
                 <a:latin typeface="Calibri"/>
                 <a:ea typeface="Calibri"/>
               </a:rPr>
-              <a:t>vs Bootcamp: 24/7 AI adaptif vs jadwal mentor mahal</a:t>
-            </a:r>
-          </a:p>
-          <a:p xmlns:a="http://schemas.openxmlformats.org/drawingml/2006/main">
-            <a:r>
-              <a:rPr lang="en-US" sz="1600">
+              <a:t>vs Ruangguru/Zenius: kurikulum tetap vs roadmap personal goal-anchored</a:t>
+            </a:r>
+          </a:p>
+          <a:p>
+            <a:r>
+              <a:rPr lang="en-US" sz="1500">
                 <a:solidFill>
                   <a:srgbClr val="A8C8FF"/>
                 </a:solidFill>
                 <a:latin typeface="Calibri"/>
                 <a:ea typeface="Calibri"/>
               </a:rPr>
-              <a:t>30+ referensi riset terarsip lengkap di repo -- jarang dimiliki prototype hackathon</a:t>
+              <a:t>vs Coursera/Udemy: dropout 90%, one-size-fits-all vs adaptif per forgetting curve</a:t>
+            </a:r>
+          </a:p>
+          <a:p>
+            <a:r>
+              <a:rPr lang="en-US" sz="1500">
+                <a:solidFill>
+                  <a:srgbClr val="A8C8FF"/>
+                </a:solidFill>
+                <a:latin typeface="Calibri"/>
+                <a:ea typeface="Calibri"/>
+              </a:rPr>
+              <a:t>vs Bootcamp: jadwal mahal vs 24/7 AI adaptif Bahasa Indonesia</a:t>
+            </a:r>
+          </a:p>
+          <a:p>
+            <a:r>
+              <a:rPr lang="en-US" sz="1500">
+                <a:solidFill>
+                  <a:srgbClr val="A8C8FF"/>
+                </a:solidFill>
+                <a:latin typeface="Calibri"/>
+                <a:ea typeface="Calibri"/>
+              </a:rPr>
+              <a:t/>
+            </a:r>
+          </a:p>
+          <a:p>
+            <a:r>
+              <a:rPr lang="en-US" sz="1500">
+                <a:solidFill>
+                  <a:srgbClr val="A8C8FF"/>
+                </a:solidFill>
+                <a:latin typeface="Calibri"/>
+                <a:ea typeface="Calibri"/>
+              </a:rPr>
+              <a:t>Kuadran yang tidak ada pesaingnya: High Adaptivity x Bahasa Indonesia</a:t>
             </a:r>
           </a:p>
         </p:txBody>

</xml_diff>

<commit_message>
docs(business): expand competitive analysis — add Dicoding, Boot.dev, DataCamp
competitive-analysis.md:
- 10 competitors total (8 direct + 2 indirect)
- Added: Dicoding (800K+ Indonesian devs), Boot.dev (backend gamified),
  DataCamp (data skills platform)
- New: Competitor Profiles section with deep profiles for 3 new entrants
- New: Battlecard Summary — win/lose reasons + objection handling scripts
  for Dicoding, Boot.dev, DataCamp
- Positioning map updated: Dicoding/Boot.dev/DataCamp placed on quadrant
- New strategic framing: Serambi.ai as 'Learning OS' above content platforms
  (complementary not competitive with Dicoding/DataCamp/Boot.dev)
- Feature matrix expanded to 14 rows, 8 columns
- Threats updated: Dicoding AI addition is now Medium-High likelihood

Pitch deck slide 09 (Impact/Value):
- Competitive box now includes Dicoding, DataCamp, Boot.dev
- 'Learning OS' strategic framing added
</commit_message>
<xml_diff>
--- a/slides/serambi-pitch-deck.pptx
+++ b/slides/serambi-pitch-deck.pptx
@@ -4430,7 +4430,7 @@
           <a:lstStyle xmlns:a="http://schemas.openxmlformats.org/drawingml/2006/main"/>
           <a:p>
             <a:r>
-              <a:rPr lang="en-US" sz="1500">
+              <a:rPr lang="en-US" sz="1400">
                 <a:solidFill>
                   <a:srgbClr val="A8C8FF"/>
                 </a:solidFill>
@@ -4442,7 +4442,7 @@
           </a:p>
           <a:p>
             <a:r>
-              <a:rPr lang="en-US" sz="1500">
+              <a:rPr lang="en-US" sz="1400">
                 <a:solidFill>
                   <a:srgbClr val="A8C8FF"/>
                 </a:solidFill>
@@ -4454,62 +4454,86 @@
           </a:p>
           <a:p>
             <a:r>
-              <a:rPr lang="en-US" sz="1500">
+              <a:rPr lang="en-US" sz="1400">
                 <a:solidFill>
                   <a:srgbClr val="A8C8FF"/>
                 </a:solidFill>
                 <a:latin typeface="Calibri"/>
                 <a:ea typeface="Calibri"/>
               </a:rPr>
-              <a:t>vs Ruangguru/Zenius: kurikulum tetap vs roadmap personal goal-anchored</a:t>
+              <a:t>vs Dicoding: jalur kursus tetap vs roadmap personal goal-anchored (Dicoding 800K+ users, tapi tidak adaptif)</a:t>
             </a:r>
           </a:p>
           <a:p>
             <a:r>
-              <a:rPr lang="en-US" sz="1500">
+              <a:rPr lang="en-US" sz="1400">
                 <a:solidFill>
                   <a:srgbClr val="A8C8FF"/>
                 </a:solidFill>
                 <a:latin typeface="Calibri"/>
                 <a:ea typeface="Calibri"/>
               </a:rPr>
-              <a:t>vs Coursera/Udemy: dropout 90%, one-size-fits-all vs adaptif per forgetting curve</a:t>
+              <a:t>vs DataCamp: track data tetap, English-first, mahal vs adaptif + Bahasa Indonesia</a:t>
             </a:r>
           </a:p>
           <a:p>
             <a:r>
-              <a:rPr lang="en-US" sz="1500">
+              <a:rPr lang="en-US" sz="1400">
                 <a:solidFill>
                   <a:srgbClr val="A8C8FF"/>
                 </a:solidFill>
                 <a:latin typeface="Calibri"/>
                 <a:ea typeface="Calibri"/>
               </a:rPr>
-              <a:t>vs Bootcamp: jadwal mahal vs 24/7 AI adaptif Bahasa Indonesia</a:t>
+              <a:t>vs Boot.dev: backend-only, English vs multi-domain + Bahasa Indonesia</a:t>
             </a:r>
           </a:p>
           <a:p>
             <a:r>
-              <a:rPr lang="en-US" sz="1500">
+              <a:rPr lang="en-US" sz="1400">
                 <a:solidFill>
                   <a:srgbClr val="A8C8FF"/>
                 </a:solidFill>
                 <a:latin typeface="Calibri"/>
                 <a:ea typeface="Calibri"/>
               </a:rPr>
+              <a:t>vs Bootcamp: jadwal mahal vs 24/7 AI adaptif</a:t>
+            </a:r>
+          </a:p>
+          <a:p>
+            <a:r>
+              <a:rPr lang="en-US" sz="1400">
+                <a:solidFill>
+                  <a:srgbClr val="A8C8FF"/>
+                </a:solidFill>
+                <a:latin typeface="Calibri"/>
+                <a:ea typeface="Calibri"/>
+              </a:rPr>
               <a:t/>
             </a:r>
           </a:p>
           <a:p>
             <a:r>
-              <a:rPr lang="en-US" sz="1500">
+              <a:rPr lang="en-US" sz="1400">
                 <a:solidFill>
                   <a:srgbClr val="A8C8FF"/>
                 </a:solidFill>
                 <a:latin typeface="Calibri"/>
                 <a:ea typeface="Calibri"/>
               </a:rPr>
-              <a:t>Kuadran yang tidak ada pesaingnya: High Adaptivity x Bahasa Indonesia</a:t>
+              <a:t>Strategic framing: Serambi.ai = 'Learning OS' di atas Dicoding/DataCamp/Boot.dev</a:t>
+            </a:r>
+          </a:p>
+          <a:p>
+            <a:r>
+              <a:rPr lang="en-US" sz="1400">
+                <a:solidFill>
+                  <a:srgbClr val="A8C8FF"/>
+                </a:solidFill>
+                <a:latin typeface="Calibri"/>
+                <a:ea typeface="Calibri"/>
+              </a:rPr>
+              <a:t>Kuadran unclaimed: High Adaptivity x Bahasa Indonesia</a:t>
             </a:r>
           </a:p>
         </p:txBody>

</xml_diff>

<commit_message>
docs(business): update competitive analysis v3 with verified data — Dicoding 1.3M+, Boot.dev Socratic AI
- Dicoding: 800K+ → 1,327,000+ registered developers (523 cities, 843K+ active learners)
- Dicoding profile: add 213 classes, 42K+ challenge participants, 4 pillars, Dicoding Points gamification
- Boot.dev: add 8 core beliefs from about page, 'Avoid AI when learning' belief
- Boot.dev: document Boots AI chatbot (Socratic + in-game XP penalty for over-reliance)
- Boot.dev vs Serambi.ai: reframe as 'philosophically closest competitor' — both scaffold-not-oracle
- Pitch deck slide 09: update Dicoding reference to 1.3M+, Boot.dev note to Socratic angle
- Key market signal paragraph: update with verified 1.3M+ figure
</commit_message>
<xml_diff>
--- a/slides/serambi-pitch-deck.pptx
+++ b/slides/serambi-pitch-deck.pptx
@@ -4461,7 +4461,7 @@
                 <a:latin typeface="Calibri"/>
                 <a:ea typeface="Calibri"/>
               </a:rPr>
-              <a:t>vs Dicoding: jalur kursus tetap vs roadmap personal goal-anchored (Dicoding 800K+ users, tapi tidak adaptif)</a:t>
+              <a:t>vs Dicoding: jalur kursus tetap vs roadmap personal goal-anchored (Dicoding 1,3 juta+ pengguna, tapi tidak adaptif)</a:t>
             </a:r>
           </a:p>
           <a:p>
@@ -4485,7 +4485,7 @@
                 <a:latin typeface="Calibri"/>
                 <a:ea typeface="Calibri"/>
               </a:rPr>
-              <a:t>vs Boot.dev: backend-only, English vs multi-domain + Bahasa Indonesia</a:t>
+              <a:t>vs Boot.dev: backend-only + English-only; Boots AI sudah Socratic (closest philosopher) tapi tidak ada Bahasa Indonesia</a:t>
             </a:r>
           </a:p>
           <a:p>

</xml_diff>

<commit_message>
chore(slides): optimize pitch deck all slides + fill team slide
- All 11 slides: visual hierarchy, emoji-prefixed bullets, accent bars,
  tighter copy, separator rules
- Slide 11: filled team placeholder — M. Muchsin, solo founder;
  added bio card (stack, S2 UNNES, LLM hallucination research)
- .gitignore: add .bob/skills/ and .bob/tmp/ to prevent ephemeral
  Bob runtime artefacts from being tracked
</commit_message>
<xml_diff>
--- a/slides/serambi-pitch-deck.pptx
+++ b/slides/serambi-pitch-deck.pptx
@@ -1335,7 +1335,7 @@
 </file>
 
 <file path=ppt/slides/slide1.xml><?xml version="1.0" encoding="utf-8"?>
-<p:sld xmlns:p="http://schemas.openxmlformats.org/presentationml/2006/main">
+<p:sld xmlns:a="http://schemas.openxmlformats.org/drawingml/2006/main" xmlns:p="http://schemas.openxmlformats.org/presentationml/2006/main">
   <p:cSld>
     <p:bg>
       <p:bgPr>
@@ -1359,7 +1359,7 @@
         </p:nvSpPr>
         <p:spPr>
           <a:xfrm xmlns:a="http://schemas.openxmlformats.org/drawingml/2006/main">
-            <a:off x="540000" y="900000"/>
+            <a:off x="540000" y="1080000"/>
             <a:ext cx="10800000" cy="1080000"/>
           </a:xfrm>
           <a:prstGeom xmlns:a="http://schemas.openxmlformats.org/drawingml/2006/main" prst="rect">
@@ -1372,7 +1372,7 @@
           <a:lstStyle xmlns:a="http://schemas.openxmlformats.org/drawingml/2006/main"/>
           <a:p xmlns:a="http://schemas.openxmlformats.org/drawingml/2006/main">
             <a:r>
-              <a:rPr lang="en-US" sz="5400" b="1">
+              <a:rPr lang="en-US" sz="6000" b="1">
                 <a:solidFill>
                   <a:srgbClr val="FFFFFF"/>
                 </a:solidFill>
@@ -1392,7 +1392,7 @@
         </p:nvSpPr>
         <p:spPr>
           <a:xfrm xmlns:a="http://schemas.openxmlformats.org/drawingml/2006/main">
-            <a:off x="540000" y="2340000"/>
+            <a:off x="540000" y="2592000"/>
             <a:ext cx="10800000" cy="540000"/>
           </a:xfrm>
           <a:prstGeom xmlns:a="http://schemas.openxmlformats.org/drawingml/2006/main" prst="rect">
@@ -1405,7 +1405,7 @@
           <a:lstStyle xmlns:a="http://schemas.openxmlformats.org/drawingml/2006/main"/>
           <a:p xmlns:a="http://schemas.openxmlformats.org/drawingml/2006/main">
             <a:r>
-              <a:rPr lang="en-US" sz="2400">
+              <a:rPr lang="en-US" sz="2600">
                 <a:solidFill>
                   <a:srgbClr val="A8C8FF"/>
                 </a:solidFill>
@@ -1425,7 +1425,7 @@
         </p:nvSpPr>
         <p:spPr>
           <a:xfrm xmlns:a="http://schemas.openxmlformats.org/drawingml/2006/main">
-            <a:off x="540000" y="3060000"/>
+            <a:off x="540000" y="3312000"/>
             <a:ext cx="10800000" cy="432000"/>
           </a:xfrm>
           <a:prstGeom xmlns:a="http://schemas.openxmlformats.org/drawingml/2006/main" prst="rect">
@@ -1438,7 +1438,7 @@
           <a:lstStyle xmlns:a="http://schemas.openxmlformats.org/drawingml/2006/main"/>
           <a:p xmlns:a="http://schemas.openxmlformats.org/drawingml/2006/main">
             <a:r>
-              <a:rPr lang="en-US" sz="1800">
+              <a:rPr lang="en-US" sz="2000">
                 <a:solidFill>
                   <a:srgbClr val="C8DCFF"/>
                 </a:solidFill>
@@ -1458,7 +1458,7 @@
         </p:nvSpPr>
         <p:spPr>
           <a:xfrm xmlns:a="http://schemas.openxmlformats.org/drawingml/2006/main">
-            <a:off x="540000" y="3960000"/>
+            <a:off x="540000" y="4320000"/>
             <a:ext cx="10800000" cy="360000"/>
           </a:xfrm>
           <a:prstGeom xmlns:a="http://schemas.openxmlformats.org/drawingml/2006/main" prst="rect">
@@ -1471,15 +1471,45 @@
           <a:lstStyle xmlns:a="http://schemas.openxmlformats.org/drawingml/2006/main"/>
           <a:p xmlns:a="http://schemas.openxmlformats.org/drawingml/2006/main">
             <a:r>
-              <a:rPr lang="en-US" sz="1400">
-                <a:solidFill>
-                  <a:srgbClr val="8AAADD"/>
+              <a:rPr lang="en-US" sz="1300">
+                <a:solidFill>
+                  <a:srgbClr val="7799CC"/>
                 </a:solidFill>
                 <a:latin typeface="Calibri"/>
                 <a:ea typeface="Calibri"/>
               </a:rPr>
               <a:t>IBM SkillsBuild University Education National Hackathon · Hacktiv8 × IBM × Komdigi</a:t>
             </a:r>
+          </a:p>
+        </p:txBody>
+      </p:sp>
+      <p:sp>
+        <p:nvSpPr>
+          <p:cNvPr id="100059" name="AccentBar"/>
+          <p:cNvSpPr txBox="1"/>
+          <p:nvPr/>
+        </p:nvSpPr>
+        <p:spPr>
+          <a:xfrm>
+            <a:off x="540000" y="2412000"/>
+            <a:ext cx="2880000" cy="64800"/>
+          </a:xfrm>
+          <a:prstGeom prst="rect">
+            <a:avLst/>
+          </a:prstGeom>
+          <a:solidFill>
+            <a:srgbClr val="4FC3F7"/>
+          </a:solidFill>
+        </p:spPr>
+        <p:txBody>
+          <a:bodyPr/>
+          <a:lstStyle/>
+          <a:p>
+            <a:endParaRPr lang="en-US">
+              <a:solidFill>
+                <a:srgbClr val="4FC3F7"/>
+              </a:solidFill>
+            </a:endParaRPr>
           </a:p>
         </p:txBody>
       </p:sp>
@@ -1489,7 +1519,7 @@
 </file>
 
 <file path=ppt/slides/slide10.xml><?xml version="1.0" encoding="utf-8"?>
-<p:sld xmlns:p="http://schemas.openxmlformats.org/presentationml/2006/main">
+<p:sld xmlns:a="http://schemas.openxmlformats.org/drawingml/2006/main" xmlns:p="http://schemas.openxmlformats.org/presentationml/2006/main">
   <p:cSld>
     <p:bg>
       <p:bgPr>
@@ -1623,52 +1653,52 @@
         <p:txBody>
           <a:bodyPr xmlns:a="http://schemas.openxmlformats.org/drawingml/2006/main"/>
           <a:lstStyle xmlns:a="http://schemas.openxmlformats.org/drawingml/2006/main"/>
-          <a:p xmlns:a="http://schemas.openxmlformats.org/drawingml/2006/main">
+          <a:p>
             <a:r>
               <a:rPr lang="en-US" sz="1600">
                 <a:solidFill>
-                  <a:srgbClr val="227722"/>
-                </a:solidFill>
-                <a:latin typeface="Calibri"/>
-                <a:ea typeface="Calibri"/>
-              </a:rPr>
-              <a:t>[DONE] Goal Agent -- e2e verified</a:t>
-            </a:r>
-          </a:p>
-          <a:p xmlns:a="http://schemas.openxmlformats.org/drawingml/2006/main">
+                  <a:srgbClr val="1A7A1A"/>
+                </a:solidFill>
+                <a:latin typeface="Calibri"/>
+                <a:ea typeface="Calibri"/>
+              </a:rPr>
+              <a:t>✅  Goal Agent — e2e verified</a:t>
+            </a:r>
+          </a:p>
+          <a:p>
             <a:r>
               <a:rPr lang="en-US" sz="1600">
                 <a:solidFill>
-                  <a:srgbClr val="227722"/>
-                </a:solidFill>
-                <a:latin typeface="Calibri"/>
-                <a:ea typeface="Calibri"/>
-              </a:rPr>
-              <a:t>[DONE] Infra MCP + Langflow + Bob</a:t>
-            </a:r>
-          </a:p>
-          <a:p xmlns:a="http://schemas.openxmlformats.org/drawingml/2006/main">
+                  <a:srgbClr val="1A7A1A"/>
+                </a:solidFill>
+                <a:latin typeface="Calibri"/>
+                <a:ea typeface="Calibri"/>
+              </a:rPr>
+              <a:t>✅  Infra MCP + Langflow + Bob</a:t>
+            </a:r>
+          </a:p>
+          <a:p>
             <a:r>
               <a:rPr lang="en-US" sz="1600">
                 <a:solidFill>
-                  <a:srgbClr val="227722"/>
-                </a:solidFill>
-                <a:latin typeface="Calibri"/>
-                <a:ea typeface="Calibri"/>
-              </a:rPr>
-              <a:t>[DONE] Dokumentasi + submission draft</a:t>
-            </a:r>
-          </a:p>
-          <a:p xmlns:a="http://schemas.openxmlformats.org/drawingml/2006/main">
+                  <a:srgbClr val="1A7A1A"/>
+                </a:solidFill>
+                <a:latin typeface="Calibri"/>
+                <a:ea typeface="Calibri"/>
+              </a:rPr>
+              <a:t>✅  Dokumentasi + submission draft</a:t>
+            </a:r>
+          </a:p>
+          <a:p>
             <a:r>
               <a:rPr lang="en-US" sz="1600">
                 <a:solidFill>
-                  <a:srgbClr val="227722"/>
-                </a:solidFill>
-                <a:latin typeface="Calibri"/>
-                <a:ea typeface="Calibri"/>
-              </a:rPr>
-              <a:t>[DONE] Verification scripts (flow + e2e)</a:t>
+                  <a:srgbClr val="1A7A1A"/>
+                </a:solidFill>
+                <a:latin typeface="Calibri"/>
+                <a:ea typeface="Calibri"/>
+              </a:rPr>
+              <a:t>✅  Verification scripts (flow + e2e)</a:t>
             </a:r>
           </a:p>
         </p:txBody>
@@ -1725,7 +1755,7 @@
         <p:txBody>
           <a:bodyPr xmlns:a="http://schemas.openxmlformats.org/drawingml/2006/main"/>
           <a:lstStyle xmlns:a="http://schemas.openxmlformats.org/drawingml/2006/main"/>
-          <a:p xmlns:a="http://schemas.openxmlformats.org/drawingml/2006/main">
+          <a:p>
             <a:r>
               <a:rPr lang="en-US" sz="1600">
                 <a:solidFill>
@@ -1734,10 +1764,10 @@
                 <a:latin typeface="Calibri"/>
                 <a:ea typeface="Calibri"/>
               </a:rPr>
-              <a:t>[ ] Tutor Agent (Feynman)</a:t>
-            </a:r>
-          </a:p>
-          <a:p xmlns:a="http://schemas.openxmlformats.org/drawingml/2006/main">
+              <a:t>◻  Tutor Agent (Feynman)</a:t>
+            </a:r>
+          </a:p>
+          <a:p>
             <a:r>
               <a:rPr lang="en-US" sz="1600">
                 <a:solidFill>
@@ -1746,10 +1776,10 @@
                 <a:latin typeface="Calibri"/>
                 <a:ea typeface="Calibri"/>
               </a:rPr>
-              <a:t>[ ] Assessment Agent (hinting)</a:t>
-            </a:r>
-          </a:p>
-          <a:p xmlns:a="http://schemas.openxmlformats.org/drawingml/2006/main">
+              <a:t>◻  Assessment Agent (hinting)</a:t>
+            </a:r>
+          </a:p>
+          <a:p>
             <a:r>
               <a:rPr lang="en-US" sz="1600">
                 <a:solidFill>
@@ -1758,10 +1788,10 @@
                 <a:latin typeface="Calibri"/>
                 <a:ea typeface="Calibri"/>
               </a:rPr>
-              <a:t>[ ] Progress Agent (spaced rep)</a:t>
-            </a:r>
-          </a:p>
-          <a:p xmlns:a="http://schemas.openxmlformats.org/drawingml/2006/main">
+              <a:t>◻  Progress Agent (spaced rep)</a:t>
+            </a:r>
+          </a:p>
+          <a:p>
             <a:r>
               <a:rPr lang="en-US" sz="1600">
                 <a:solidFill>
@@ -1770,10 +1800,10 @@
                 <a:latin typeface="Calibri"/>
                 <a:ea typeface="Calibri"/>
               </a:rPr>
-              <a:t>[ ] Motivator + Wellbeing Agent</a:t>
-            </a:r>
-          </a:p>
-          <a:p xmlns:a="http://schemas.openxmlformats.org/drawingml/2006/main">
+              <a:t>◻  Motivator + Wellbeing Agent</a:t>
+            </a:r>
+          </a:p>
+          <a:p>
             <a:r>
               <a:rPr lang="en-US" sz="1600">
                 <a:solidFill>
@@ -1782,10 +1812,10 @@
                 <a:latin typeface="Calibri"/>
                 <a:ea typeface="Calibri"/>
               </a:rPr>
-              <a:t>[ ] Web App (antarmuka pengguna)</a:t>
-            </a:r>
-          </a:p>
-          <a:p xmlns:a="http://schemas.openxmlformats.org/drawingml/2006/main">
+              <a:t>◻  Web App (antarmuka pengguna)</a:t>
+            </a:r>
+          </a:p>
+          <a:p>
             <a:r>
               <a:rPr lang="en-US" sz="1600">
                 <a:solidFill>
@@ -1794,7 +1824,7 @@
                 <a:latin typeface="Calibri"/>
                 <a:ea typeface="Calibri"/>
               </a:rPr>
-              <a:t>[ ] WhatsApp bot surface</a:t>
+              <a:t>◻  WhatsApp bot surface</a:t>
             </a:r>
           </a:p>
         </p:txBody>
@@ -1818,40 +1848,28 @@
         <p:txBody>
           <a:bodyPr xmlns:a="http://schemas.openxmlformats.org/drawingml/2006/main"/>
           <a:lstStyle xmlns:a="http://schemas.openxmlformats.org/drawingml/2006/main"/>
-          <a:p xmlns:a="http://schemas.openxmlformats.org/drawingml/2006/main">
-            <a:r>
-              <a:rPr lang="en-US" sz="1600">
+          <a:p>
+            <a:r>
+              <a:rPr lang="en-US" sz="1500">
                 <a:solidFill>
                   <a:srgbClr val="333333"/>
                 </a:solidFill>
                 <a:latin typeface="Calibri"/>
                 <a:ea typeface="Calibri"/>
               </a:rPr>
-              <a:t>Roadmap B2B:</a:t>
-            </a:r>
-          </a:p>
-          <a:p xmlns:a="http://schemas.openxmlformats.org/drawingml/2006/main">
-            <a:r>
-              <a:rPr lang="en-US" sz="1600">
+              <a:t>Roadmap B2B:  Whitelabel untuk bootcamp, kampus, program reskilling Komdigi</a:t>
+            </a:r>
+          </a:p>
+          <a:p>
+            <a:r>
+              <a:rPr lang="en-US" sz="1500">
                 <a:solidFill>
                   <a:srgbClr val="333333"/>
                 </a:solidFill>
                 <a:latin typeface="Calibri"/>
                 <a:ea typeface="Calibri"/>
               </a:rPr>
-              <a:t>Whitelabel untuk bootcamp, kampus, program reskilling Komdigi</a:t>
-            </a:r>
-          </a:p>
-          <a:p xmlns:a="http://schemas.openxmlformats.org/drawingml/2006/main">
-            <a:r>
-              <a:rPr lang="en-US" sz="1600">
-                <a:solidFill>
-                  <a:srgbClr val="333333"/>
-                </a:solidFill>
-                <a:latin typeface="Calibri"/>
-                <a:ea typeface="Calibri"/>
-              </a:rPr>
-              <a:t>Satu instansi - ribuan peserta - biaya per pengguna rendah</a:t>
+              <a:t>Satu instansi — ribuan peserta — biaya per pengguna rendah</a:t>
             </a:r>
           </a:p>
         </p:txBody>
@@ -1875,30 +1893,45 @@
         <p:txBody>
           <a:bodyPr xmlns:a="http://schemas.openxmlformats.org/drawingml/2006/main"/>
           <a:lstStyle xmlns:a="http://schemas.openxmlformats.org/drawingml/2006/main"/>
-          <a:p xmlns:a="http://schemas.openxmlformats.org/drawingml/2006/main">
-            <a:r>
-              <a:rPr lang="en-US" sz="1500">
+          <a:p>
+            <a:r>
+              <a:rPr lang="en-US" sz="1300">
                 <a:solidFill>
                   <a:srgbClr val="777777"/>
                 </a:solidFill>
                 <a:latin typeface="Calibri"/>
                 <a:ea typeface="Calibri"/>
               </a:rPr>
-              <a:t>Skala teknis: Langflow Cloud multi-tenant + analytics dashboard progres</a:t>
-            </a:r>
-          </a:p>
-          <a:p xmlns:a="http://schemas.openxmlformats.org/drawingml/2006/main">
-            <a:r>
-              <a:rPr lang="en-US" sz="1500">
-                <a:solidFill>
-                  <a:srgbClr val="777777"/>
-                </a:solidFill>
-                <a:latin typeface="Calibri"/>
-                <a:ea typeface="Calibri"/>
-              </a:rPr>
-              <a:t>Moat jangka panjang: model forgetting curve anonim per domain</a:t>
-            </a:r>
-          </a:p>
+              <a:t>Skala teknis: Langflow Cloud multi-tenant + analytics progres  ·  Moat: model forgetting curve anonim per domain</a:t>
+            </a:r>
+          </a:p>
+        </p:txBody>
+      </p:sp>
+      <p:sp>
+        <p:nvSpPr>
+          <p:cNvPr id="100066" name="TextBox 9"/>
+          <p:cNvSpPr/>
+          <p:nvPr/>
+        </p:nvSpPr>
+        <p:spPr>
+          <a:xfrm>
+            <a:off x="540000" y="1116000"/>
+            <a:ext cx="1260000" cy="21600"/>
+          </a:xfrm>
+          <a:prstGeom prst="rect">
+            <a:avLst/>
+          </a:prstGeom>
+          <a:solidFill>
+            <a:srgbClr val="1E2761"/>
+          </a:solidFill>
+          <a:ln>
+            <a:noFill/>
+          </a:ln>
+        </p:spPr>
+        <p:txBody>
+          <a:bodyPr/>
+          <a:lstStyle/>
+          <a:p/>
         </p:txBody>
       </p:sp>
     </p:spTree>
@@ -1907,7 +1940,7 @@
 </file>
 
 <file path=ppt/slides/slide11.xml><?xml version="1.0" encoding="utf-8"?>
-<p:sld xmlns:p="http://schemas.openxmlformats.org/presentationml/2006/main">
+<p:sld xmlns:a="http://schemas.openxmlformats.org/drawingml/2006/main" xmlns:p="http://schemas.openxmlformats.org/presentationml/2006/main">
   <p:cSld>
     <p:bg>
       <p:bgPr>
@@ -1984,7 +2017,7 @@
                 <a:latin typeface="Calibri"/>
                 <a:ea typeface="Calibri"/>
               </a:rPr>
-              <a:t>Tim</a:t>
+              <a:t>Tim &amp; Founder</a:t>
             </a:r>
           </a:p>
         </p:txBody>
@@ -1997,27 +2030,27 @@
         </p:nvSpPr>
         <p:spPr>
           <a:xfrm xmlns:a="http://schemas.openxmlformats.org/drawingml/2006/main">
-            <a:off x="540000" y="1260000"/>
-            <a:ext cx="10800000" cy="720000"/>
-          </a:xfrm>
-          <a:prstGeom xmlns:a="http://schemas.openxmlformats.org/drawingml/2006/main" prst="rect">
-            <a:avLst/>
-          </a:prstGeom>
-          <a:noFill xmlns:a="http://schemas.openxmlformats.org/drawingml/2006/main"/>
-        </p:spPr>
-        <p:txBody>
-          <a:bodyPr xmlns:a="http://schemas.openxmlformats.org/drawingml/2006/main"/>
-          <a:lstStyle xmlns:a="http://schemas.openxmlformats.org/drawingml/2006/main"/>
-          <a:p xmlns:a="http://schemas.openxmlformats.org/drawingml/2006/main">
-            <a:r>
-              <a:rPr lang="en-US" sz="2200">
-                <a:solidFill>
-                  <a:srgbClr val="A8C8FF"/>
-                </a:solidFill>
-                <a:latin typeface="Calibri"/>
-                <a:ea typeface="Calibri"/>
-              </a:rPr>
-              <a:t>[ Isi nama dan peran anggota tim di sini ]</a:t>
+            <a:off x="540000" y="1152000"/>
+            <a:ext cx="10800000" cy="540000"/>
+          </a:xfrm>
+          <a:prstGeom xmlns:a="http://schemas.openxmlformats.org/drawingml/2006/main" prst="rect">
+            <a:avLst/>
+          </a:prstGeom>
+          <a:noFill xmlns:a="http://schemas.openxmlformats.org/drawingml/2006/main"/>
+        </p:spPr>
+        <p:txBody>
+          <a:bodyPr xmlns:a="http://schemas.openxmlformats.org/drawingml/2006/main"/>
+          <a:lstStyle xmlns:a="http://schemas.openxmlformats.org/drawingml/2006/main"/>
+          <a:p xmlns:a="http://schemas.openxmlformats.org/drawingml/2006/main">
+            <a:r>
+              <a:rPr lang="en-US" sz="2600" b="1">
+                <a:solidFill>
+                  <a:srgbClr val="FFFFFF"/>
+                </a:solidFill>
+                <a:latin typeface="Calibri"/>
+                <a:ea typeface="Calibri"/>
+              </a:rPr>
+              <a:t>M. Muchsin  —  Solo Founder &amp; Engineer</a:t>
             </a:r>
           </a:p>
         </p:txBody>
@@ -2030,7 +2063,7 @@
         </p:nvSpPr>
         <p:spPr>
           <a:xfrm xmlns:a="http://schemas.openxmlformats.org/drawingml/2006/main">
-            <a:off x="540000" y="2160000"/>
+            <a:off x="540000" y="2340000"/>
             <a:ext cx="10800000" cy="1800000"/>
           </a:xfrm>
           <a:prstGeom xmlns:a="http://schemas.openxmlformats.org/drawingml/2006/main" prst="rect">
@@ -2041,21 +2074,21 @@
         <p:txBody>
           <a:bodyPr xmlns:a="http://schemas.openxmlformats.org/drawingml/2006/main"/>
           <a:lstStyle xmlns:a="http://schemas.openxmlformats.org/drawingml/2006/main"/>
-          <a:p xmlns:a="http://schemas.openxmlformats.org/drawingml/2006/main">
-            <a:r>
-              <a:rPr lang="en-US" sz="1800">
+          <a:p>
+            <a:r>
+              <a:rPr lang="en-US" sz="1700">
                 <a:solidFill>
                   <a:srgbClr val="C8DCFF"/>
                 </a:solidFill>
                 <a:latin typeface="Calibri"/>
                 <a:ea typeface="Calibri"/>
               </a:rPr>
-              <a:t>Mengapa tim ini:</a:t>
-            </a:r>
-          </a:p>
-          <a:p xmlns:a="http://schemas.openxmlformats.org/drawingml/2006/main">
-            <a:r>
-              <a:rPr lang="en-US" sz="1800">
+              <a:t>Mengapa founder ini:</a:t>
+            </a:r>
+          </a:p>
+          <a:p>
+            <a:r>
+              <a:rPr lang="en-US" sz="1700">
                 <a:solidFill>
                   <a:srgbClr val="C8DCFF"/>
                 </a:solidFill>
@@ -2065,52 +2098,52 @@
               <a:t/>
             </a:r>
           </a:p>
-          <a:p xmlns:a="http://schemas.openxmlformats.org/drawingml/2006/main">
-            <a:r>
-              <a:rPr lang="en-US" sz="1800">
+          <a:p>
+            <a:r>
+              <a:rPr lang="en-US" sz="1700">
                 <a:solidFill>
                   <a:srgbClr val="C8DCFF"/>
                 </a:solidFill>
                 <a:latin typeface="Calibri"/>
                 <a:ea typeface="Calibri"/>
               </a:rPr>
-              <a:t>Riset mendalam -- 30+ paper dengan abstract dan DOI, bukan sekadar klaim</a:t>
-            </a:r>
-          </a:p>
-          <a:p xmlns:a="http://schemas.openxmlformats.org/drawingml/2006/main">
-            <a:r>
-              <a:rPr lang="en-US" sz="1800">
+              <a:t>📄  Riset mendalam — 30+ paper (abstract + DOI); topik riset S2 langsung: LLM hallucination reduction</a:t>
+            </a:r>
+          </a:p>
+          <a:p>
+            <a:r>
+              <a:rPr lang="en-US" sz="1700">
                 <a:solidFill>
                   <a:srgbClr val="C8DCFF"/>
                 </a:solidFill>
                 <a:latin typeface="Calibri"/>
                 <a:ea typeface="Calibri"/>
               </a:rPr>
-              <a:t>Implementasi nyata -- Goal Agent e2e verified, bukan hanya mockup</a:t>
-            </a:r>
-          </a:p>
-          <a:p xmlns:a="http://schemas.openxmlformats.org/drawingml/2006/main">
-            <a:r>
-              <a:rPr lang="en-US" sz="1800">
+              <a:t>✅  Implementasi nyata — Goal Agent e2e verified; bukan mockup, bukan demo palsu</a:t>
+            </a:r>
+          </a:p>
+          <a:p>
+            <a:r>
+              <a:rPr lang="en-US" sz="1700">
                 <a:solidFill>
                   <a:srgbClr val="C8DCFF"/>
                 </a:solidFill>
                 <a:latin typeface="Calibri"/>
                 <a:ea typeface="Calibri"/>
               </a:rPr>
-              <a:t>Arsitektur modular -- tiap agent bisa dikembangkan dan diganti secara independen</a:t>
-            </a:r>
-          </a:p>
-          <a:p xmlns:a="http://schemas.openxmlformats.org/drawingml/2006/main">
-            <a:r>
-              <a:rPr lang="en-US" sz="1800">
+              <a:t>🔧  Full-stack &amp; agentic — Vue/Nuxt/SvelteKit + agentic AI; paham stack produksi sampai infra agent</a:t>
+            </a:r>
+          </a:p>
+          <a:p>
+            <a:r>
+              <a:rPr lang="en-US" sz="1700">
                 <a:solidFill>
                   <a:srgbClr val="C8DCFF"/>
                 </a:solidFill>
                 <a:latin typeface="Calibri"/>
                 <a:ea typeface="Calibri"/>
               </a:rPr>
-              <a:t>Pedagogi berbasis bukti -- setiap fitur terhubung ke paper dengan FWCI tinggi</a:t>
+              <a:t>🎓  Pedagogi berbasis bukti — setiap fitur terhubung ke paper dengan FWCI tinggi</a:t>
             </a:r>
           </a:p>
         </p:txBody>
@@ -2134,28 +2167,96 @@
         <p:txBody>
           <a:bodyPr xmlns:a="http://schemas.openxmlformats.org/drawingml/2006/main"/>
           <a:lstStyle xmlns:a="http://schemas.openxmlformats.org/drawingml/2006/main"/>
-          <a:p xmlns:a="http://schemas.openxmlformats.org/drawingml/2006/main">
-            <a:r>
-              <a:rPr lang="en-US" sz="1600">
+          <a:p>
+            <a:r>
+              <a:rPr lang="en-US" sz="1500">
                 <a:solidFill>
                   <a:srgbClr val="A8C8FF"/>
                 </a:solidFill>
                 <a:latin typeface="Calibri"/>
                 <a:ea typeface="Calibri"/>
               </a:rPr>
-              <a:t>Repo: https://github.com/mmuchsin/serambi-ai</a:t>
-            </a:r>
-          </a:p>
-          <a:p xmlns:a="http://schemas.openxmlformats.org/drawingml/2006/main">
-            <a:r>
-              <a:rPr lang="en-US" sz="1600">
+              <a:t>🔗  github.com/mmuchsin/serambi-ai</a:t>
+            </a:r>
+          </a:p>
+          <a:p>
+            <a:r>
+              <a:rPr lang="en-US" sz="1500">
                 <a:solidFill>
                   <a:srgbClr val="A8C8FF"/>
                 </a:solidFill>
                 <a:latin typeface="Calibri"/>
                 <a:ea typeface="Calibri"/>
               </a:rPr>
-              <a:t>Stack: IBM Bob x IBM Langflow x MCP x NaraRouter</a:t>
+              <a:t>Stack: IBM Bob × IBM Langflow × MCP × NaraRouter</a:t>
+            </a:r>
+          </a:p>
+        </p:txBody>
+      </p:sp>
+      <p:sp>
+        <p:nvSpPr>
+          <p:cNvPr id="100067" name="TextBox 6"/>
+          <p:cNvSpPr/>
+          <p:nvPr/>
+        </p:nvSpPr>
+        <p:spPr>
+          <a:xfrm>
+            <a:off x="540000" y="2088000"/>
+            <a:ext cx="10800000" cy="21600"/>
+          </a:xfrm>
+          <a:prstGeom prst="rect">
+            <a:avLst/>
+          </a:prstGeom>
+          <a:solidFill>
+            <a:srgbClr val="4499BB"/>
+          </a:solidFill>
+          <a:ln>
+            <a:noFill/>
+          </a:ln>
+        </p:spPr>
+        <p:txBody>
+          <a:bodyPr/>
+          <a:lstStyle/>
+          <a:p/>
+        </p:txBody>
+      </p:sp>
+      <p:sp>
+        <p:nvSpPr>
+          <p:cNvPr id="100068" name="TextBox 7"/>
+          <p:cNvSpPr txBox="1"/>
+          <p:nvPr/>
+        </p:nvSpPr>
+        <p:spPr>
+          <a:xfrm>
+            <a:off x="540000" y="1800000"/>
+            <a:ext cx="10800000" cy="648000"/>
+          </a:xfrm>
+          <a:prstGeom prst="rect">
+            <a:avLst/>
+          </a:prstGeom>
+          <a:noFill/>
+        </p:spPr>
+        <p:txBody>
+          <a:bodyPr/>
+          <a:lstStyle/>
+          <a:p>
+            <a:r>
+              <a:rPr lang="en-US" sz="1500" i="1">
+                <a:solidFill>
+                  <a:srgbClr val="C8DCFF"/>
+                </a:solidFill>
+              </a:rPr>
+              <a:t>Software Engineer · Vue / Nuxt / TypeScript · SvelteKit · Agentic AI</a:t>
+            </a:r>
+          </a:p>
+          <a:p>
+            <a:r>
+              <a:rPr lang="en-US" sz="1500" i="1">
+                <a:solidFill>
+                  <a:srgbClr val="C8DCFF"/>
+                </a:solidFill>
+              </a:rPr>
+              <a:t>S2 Informatika — Universitas Negeri Semarang (UNNES) · Riset: LLM Hallucination Reduction</a:t>
             </a:r>
           </a:p>
         </p:txBody>
@@ -2166,7 +2267,7 @@
 </file>
 
 <file path=ppt/slides/slide2.xml><?xml version="1.0" encoding="utf-8"?>
-<p:sld xmlns:p="http://schemas.openxmlformats.org/presentationml/2006/main">
+<p:sld xmlns:a="http://schemas.openxmlformats.org/drawingml/2006/main" xmlns:p="http://schemas.openxmlformats.org/presentationml/2006/main">
   <p:cSld>
     <p:bg>
       <p:bgPr>
@@ -2236,7 +2337,7 @@
           <a:lstStyle xmlns:a="http://schemas.openxmlformats.org/drawingml/2006/main"/>
           <a:p xmlns:a="http://schemas.openxmlformats.org/drawingml/2006/main">
             <a:r>
-              <a:rPr lang="en-US" sz="3600" b="1">
+              <a:rPr lang="en-US" sz="3400" b="1">
                 <a:solidFill>
                   <a:srgbClr val="1E2761"/>
                 </a:solidFill>
@@ -2256,8 +2357,8 @@
         </p:nvSpPr>
         <p:spPr>
           <a:xfrm xmlns:a="http://schemas.openxmlformats.org/drawingml/2006/main">
-            <a:off x="540000" y="1152000"/>
-            <a:ext cx="10800000" cy="432000"/>
+            <a:off x="540000" y="1224000"/>
+            <a:ext cx="10800000" cy="360000"/>
           </a:xfrm>
           <a:prstGeom xmlns:a="http://schemas.openxmlformats.org/drawingml/2006/main" prst="rect">
             <a:avLst/>
@@ -2289,7 +2390,7 @@
         </p:nvSpPr>
         <p:spPr>
           <a:xfrm xmlns:a="http://schemas.openxmlformats.org/drawingml/2006/main">
-            <a:off x="540000" y="1692000"/>
+            <a:off x="540000" y="1728000"/>
             <a:ext cx="10800000" cy="2880000"/>
           </a:xfrm>
           <a:prstGeom xmlns:a="http://schemas.openxmlformats.org/drawingml/2006/main" prst="rect">
@@ -2300,7 +2401,7 @@
         <p:txBody>
           <a:bodyPr xmlns:a="http://schemas.openxmlformats.org/drawingml/2006/main"/>
           <a:lstStyle xmlns:a="http://schemas.openxmlformats.org/drawingml/2006/main"/>
-          <a:p xmlns:a="http://schemas.openxmlformats.org/drawingml/2006/main">
+          <a:p>
             <a:r>
               <a:rPr lang="en-US" sz="1800">
                 <a:solidFill>
@@ -2309,10 +2410,10 @@
                 <a:latin typeface="Calibri"/>
                 <a:ea typeface="Calibri"/>
               </a:rPr>
-              <a:t>X  Tidak ada roadmap personal -- materi acak dari YouTube, Udemy, blog tanpa dipetakan ke skill gap target role.</a:t>
-            </a:r>
-          </a:p>
-          <a:p xmlns:a="http://schemas.openxmlformats.org/drawingml/2006/main">
+              <a:t>✗  Tidak ada roadmap personal — materi acak (YouTube, Udemy, blog) tanpa peta ke target role.</a:t>
+            </a:r>
+          </a:p>
+          <a:p>
             <a:r>
               <a:rPr lang="en-US" sz="1800">
                 <a:solidFill>
@@ -2324,7 +2425,7 @@
               <a:t/>
             </a:r>
           </a:p>
-          <a:p xmlns:a="http://schemas.openxmlformats.org/drawingml/2006/main">
+          <a:p>
             <a:r>
               <a:rPr lang="en-US" sz="1800">
                 <a:solidFill>
@@ -2333,10 +2434,10 @@
                 <a:latin typeface="Calibri"/>
                 <a:ea typeface="Calibri"/>
               </a:rPr>
-              <a:t>X  Progres tidak terlacak -- tidak ada jawaban untuk sudah sejauh mana, harus lanjut ke apa?</a:t>
-            </a:r>
-          </a:p>
-          <a:p xmlns:a="http://schemas.openxmlformats.org/drawingml/2006/main">
+              <a:t>✗  Progres tidak terlacak — tidak ada jawaban: sudah sejauh mana? harus lanjut ke apa?</a:t>
+            </a:r>
+          </a:p>
+          <a:p>
             <a:r>
               <a:rPr lang="en-US" sz="1800">
                 <a:solidFill>
@@ -2348,7 +2449,7 @@
               <a:t/>
             </a:r>
           </a:p>
-          <a:p xmlns:a="http://schemas.openxmlformats.org/drawingml/2006/main">
+          <a:p>
             <a:r>
               <a:rPr lang="en-US" sz="1800">
                 <a:solidFill>
@@ -2357,10 +2458,10 @@
                 <a:latin typeface="Calibri"/>
                 <a:ea typeface="Calibri"/>
               </a:rPr>
-              <a:t>X  AI generik memicu cognitive offloading -- langsung dijawab, tanpa belajar aktif. (BJET, dikutip 694x)</a:t>
-            </a:r>
-          </a:p>
-          <a:p xmlns:a="http://schemas.openxmlformats.org/drawingml/2006/main">
+              <a:t>✗  AI generik memicu cognitive offloading — langsung dijawab, tanpa belajar aktif. (BJET, 694× dikutip)</a:t>
+            </a:r>
+          </a:p>
+          <a:p>
             <a:r>
               <a:rPr lang="en-US" sz="1800">
                 <a:solidFill>
@@ -2372,7 +2473,7 @@
               <a:t/>
             </a:r>
           </a:p>
-          <a:p xmlns:a="http://schemas.openxmlformats.org/drawingml/2006/main">
+          <a:p>
             <a:r>
               <a:rPr lang="en-US" sz="1800">
                 <a:solidFill>
@@ -2381,7 +2482,7 @@
                 <a:latin typeface="Calibri"/>
                 <a:ea typeface="Calibri"/>
               </a:rPr>
-              <a:t>X  Alternatif mahal -- bootcamp &amp; mentor privat tidak terjangkau; kursus online one-size-fits-all.</a:t>
+              <a:t>✗  Alternatif mahal — bootcamp &amp; mentor privat tidak terjangkau; kursus online one-size-fits-all.</a:t>
             </a:r>
           </a:p>
         </p:txBody>
@@ -2407,15 +2508,45 @@
           <a:lstStyle xmlns:a="http://schemas.openxmlformats.org/drawingml/2006/main"/>
           <a:p xmlns:a="http://schemas.openxmlformats.org/drawingml/2006/main">
             <a:r>
-              <a:rPr lang="en-US" sz="1400">
-                <a:solidFill>
-                  <a:srgbClr val="777777"/>
-                </a:solidFill>
-                <a:latin typeface="Calibri"/>
-                <a:ea typeface="Calibri"/>
-              </a:rPr>
-              <a:t>Market upskilling global tumbuh 11-14% CAGR -- tapi sebagian besar B2B/korporasi. Career switcher individu terlewat.</a:t>
-            </a:r>
+              <a:rPr lang="en-US" sz="1300">
+                <a:solidFill>
+                  <a:srgbClr val="555555"/>
+                </a:solidFill>
+                <a:latin typeface="Calibri"/>
+                <a:ea typeface="Calibri"/>
+              </a:rPr>
+              <a:t>📈  Market upskilling global tumbuh 11–14% CAGR — tapi hampir seluruhnya B2B/korporasi. Career switcher individu tidak terlayani.</a:t>
+            </a:r>
+          </a:p>
+        </p:txBody>
+      </p:sp>
+      <p:sp>
+        <p:nvSpPr>
+          <p:cNvPr id="100060" name="AccentBar"/>
+          <p:cNvSpPr txBox="1"/>
+          <p:nvPr/>
+        </p:nvSpPr>
+        <p:spPr>
+          <a:xfrm>
+            <a:off x="540000" y="1116000"/>
+            <a:ext cx="1800000" cy="54000"/>
+          </a:xfrm>
+          <a:prstGeom prst="rect">
+            <a:avLst/>
+          </a:prstGeom>
+          <a:solidFill>
+            <a:srgbClr val="C0392B"/>
+          </a:solidFill>
+        </p:spPr>
+        <p:txBody>
+          <a:bodyPr/>
+          <a:lstStyle/>
+          <a:p>
+            <a:endParaRPr lang="en-US">
+              <a:solidFill>
+                <a:srgbClr val="C0392B"/>
+              </a:solidFill>
+            </a:endParaRPr>
           </a:p>
         </p:txBody>
       </p:sp>
@@ -2425,7 +2556,7 @@
 </file>
 
 <file path=ppt/slides/slide3.xml><?xml version="1.0" encoding="utf-8"?>
-<p:sld xmlns:p="http://schemas.openxmlformats.org/presentationml/2006/main">
+<p:sld xmlns:a="http://schemas.openxmlformats.org/drawingml/2006/main" xmlns:p="http://schemas.openxmlformats.org/presentationml/2006/main">
   <p:cSld>
     <p:bg>
       <p:bgPr>
@@ -2515,20 +2646,20 @@
         </p:nvSpPr>
         <p:spPr>
           <a:xfrm xmlns:a="http://schemas.openxmlformats.org/drawingml/2006/main">
-            <a:off x="540000" y="1152000"/>
-            <a:ext cx="10800000" cy="648000"/>
-          </a:xfrm>
-          <a:prstGeom xmlns:a="http://schemas.openxmlformats.org/drawingml/2006/main" prst="rect">
-            <a:avLst/>
-          </a:prstGeom>
-          <a:noFill xmlns:a="http://schemas.openxmlformats.org/drawingml/2006/main"/>
-        </p:spPr>
-        <p:txBody>
-          <a:bodyPr xmlns:a="http://schemas.openxmlformats.org/drawingml/2006/main"/>
-          <a:lstStyle xmlns:a="http://schemas.openxmlformats.org/drawingml/2006/main"/>
-          <a:p xmlns:a="http://schemas.openxmlformats.org/drawingml/2006/main">
-            <a:r>
-              <a:rPr lang="en-US" sz="2000">
+            <a:off x="540000" y="1224000"/>
+            <a:ext cx="10800000" cy="540000"/>
+          </a:xfrm>
+          <a:prstGeom xmlns:a="http://schemas.openxmlformats.org/drawingml/2006/main" prst="rect">
+            <a:avLst/>
+          </a:prstGeom>
+          <a:noFill xmlns:a="http://schemas.openxmlformats.org/drawingml/2006/main"/>
+        </p:spPr>
+        <p:txBody>
+          <a:bodyPr xmlns:a="http://schemas.openxmlformats.org/drawingml/2006/main"/>
+          <a:lstStyle xmlns:a="http://schemas.openxmlformats.org/drawingml/2006/main"/>
+          <a:p xmlns:a="http://schemas.openxmlformats.org/drawingml/2006/main">
+            <a:r>
+              <a:rPr lang="en-US" sz="2000" i="1">
                 <a:solidFill>
                   <a:srgbClr val="A8C8FF"/>
                 </a:solidFill>
@@ -2548,7 +2679,7 @@
         </p:nvSpPr>
         <p:spPr>
           <a:xfrm xmlns:a="http://schemas.openxmlformats.org/drawingml/2006/main">
-            <a:off x="540000" y="1980000"/>
+            <a:off x="540000" y="1872000"/>
             <a:ext cx="10800000" cy="2880000"/>
           </a:xfrm>
           <a:prstGeom xmlns:a="http://schemas.openxmlformats.org/drawingml/2006/main" prst="rect">
@@ -2559,7 +2690,7 @@
         <p:txBody>
           <a:bodyPr xmlns:a="http://schemas.openxmlformats.org/drawingml/2006/main"/>
           <a:lstStyle xmlns:a="http://schemas.openxmlformats.org/drawingml/2006/main"/>
-          <a:p xmlns:a="http://schemas.openxmlformats.org/drawingml/2006/main">
+          <a:p>
             <a:r>
               <a:rPr lang="en-US" sz="1800">
                 <a:solidFill>
@@ -2568,10 +2699,10 @@
                 <a:latin typeface="Calibri"/>
                 <a:ea typeface="Calibri"/>
               </a:rPr>
-              <a:t>Pengguna ketik goal karier: 'jadi data analyst dalam 3 bulan'</a:t>
-            </a:r>
-          </a:p>
-          <a:p xmlns:a="http://schemas.openxmlformats.org/drawingml/2006/main">
+              <a:t>1 → Pengguna ketik goal karier: "jadi data analyst dalam 3 bulan"</a:t>
+            </a:r>
+          </a:p>
+          <a:p>
             <a:r>
               <a:rPr lang="en-US" sz="1800">
                 <a:solidFill>
@@ -2583,7 +2714,7 @@
               <a:t/>
             </a:r>
           </a:p>
-          <a:p xmlns:a="http://schemas.openxmlformats.org/drawingml/2006/main">
+          <a:p>
             <a:r>
               <a:rPr lang="en-US" sz="1800">
                 <a:solidFill>
@@ -2592,10 +2723,10 @@
                 <a:latin typeface="Calibri"/>
                 <a:ea typeface="Calibri"/>
               </a:rPr>
-              <a:t>Serambi.ai memecah goal -&gt; roadmap mingguan terstruktur</a:t>
-            </a:r>
-          </a:p>
-          <a:p xmlns:a="http://schemas.openxmlformats.org/drawingml/2006/main">
+              <a:t>2 → Serambi.ai memecah goal → roadmap mingguan terstruktur</a:t>
+            </a:r>
+          </a:p>
+          <a:p>
             <a:r>
               <a:rPr lang="en-US" sz="1800">
                 <a:solidFill>
@@ -2607,7 +2738,7 @@
               <a:t/>
             </a:r>
           </a:p>
-          <a:p xmlns:a="http://schemas.openxmlformats.org/drawingml/2006/main">
+          <a:p>
             <a:r>
               <a:rPr lang="en-US" sz="1800">
                 <a:solidFill>
@@ -2616,10 +2747,10 @@
                 <a:latin typeface="Calibri"/>
                 <a:ea typeface="Calibri"/>
               </a:rPr>
-              <a:t>Agent Tutor menjelaskan konsep dengan teknik Feynman</a:t>
-            </a:r>
-          </a:p>
-          <a:p xmlns:a="http://schemas.openxmlformats.org/drawingml/2006/main">
+              <a:t>3 → Agent Tutor menjelaskan konsep dengan teknik Feynman</a:t>
+            </a:r>
+          </a:p>
+          <a:p>
             <a:r>
               <a:rPr lang="en-US" sz="1800">
                 <a:solidFill>
@@ -2631,7 +2762,7 @@
               <a:t/>
             </a:r>
           </a:p>
-          <a:p xmlns:a="http://schemas.openxmlformats.org/drawingml/2006/main">
+          <a:p>
             <a:r>
               <a:rPr lang="en-US" sz="1800">
                 <a:solidFill>
@@ -2640,10 +2771,10 @@
                 <a:latin typeface="Calibri"/>
                 <a:ea typeface="Calibri"/>
               </a:rPr>
-              <a:t>Agent Assessment memberi kuis adaptif + graduated hints</a:t>
-            </a:r>
-          </a:p>
-          <a:p xmlns:a="http://schemas.openxmlformats.org/drawingml/2006/main">
+              <a:t>4 → Agent Assessment: kuis adaptif + graduated hints</a:t>
+            </a:r>
+          </a:p>
+          <a:p>
             <a:r>
               <a:rPr lang="en-US" sz="1800">
                 <a:solidFill>
@@ -2655,7 +2786,7 @@
               <a:t/>
             </a:r>
           </a:p>
-          <a:p xmlns:a="http://schemas.openxmlformats.org/drawingml/2006/main">
+          <a:p>
             <a:r>
               <a:rPr lang="en-US" sz="1800">
                 <a:solidFill>
@@ -2664,10 +2795,10 @@
                 <a:latin typeface="Calibri"/>
                 <a:ea typeface="Calibri"/>
               </a:rPr>
-              <a:t>Agent Progress menjadwalkan review berbasis forgetting curve</a:t>
-            </a:r>
-          </a:p>
-          <a:p xmlns:a="http://schemas.openxmlformats.org/drawingml/2006/main">
+              <a:t>5 → Agent Progress: review berbasis forgetting curve</a:t>
+            </a:r>
+          </a:p>
+          <a:p>
             <a:r>
               <a:rPr lang="en-US" sz="1800">
                 <a:solidFill>
@@ -2679,7 +2810,7 @@
               <a:t/>
             </a:r>
           </a:p>
-          <a:p xmlns:a="http://schemas.openxmlformats.org/drawingml/2006/main">
+          <a:p>
             <a:r>
               <a:rPr lang="en-US" sz="1800">
                 <a:solidFill>
@@ -2688,9 +2819,36 @@
                 <a:latin typeface="Calibri"/>
                 <a:ea typeface="Calibri"/>
               </a:rPr>
-              <a:t>Agent Wellbeing memantau motivasi dan cegah burnout</a:t>
-            </a:r>
-          </a:p>
+              <a:t>6 → Agent Wellbeing: pantau motivasi, cegah burnout</a:t>
+            </a:r>
+          </a:p>
+        </p:txBody>
+      </p:sp>
+      <p:sp>
+        <p:nvSpPr>
+          <p:cNvPr id="100061" name="TextBox 5"/>
+          <p:cNvSpPr/>
+          <p:nvPr/>
+        </p:nvSpPr>
+        <p:spPr>
+          <a:xfrm>
+            <a:off x="540000" y="1800000"/>
+            <a:ext cx="1440000" cy="21600"/>
+          </a:xfrm>
+          <a:prstGeom prst="rect">
+            <a:avLst/>
+          </a:prstGeom>
+          <a:solidFill>
+            <a:srgbClr val="009FDB"/>
+          </a:solidFill>
+          <a:ln>
+            <a:noFill/>
+          </a:ln>
+        </p:spPr>
+        <p:txBody>
+          <a:bodyPr/>
+          <a:lstStyle/>
+          <a:p/>
         </p:txBody>
       </p:sp>
     </p:spTree>
@@ -2699,7 +2857,7 @@
 </file>
 
 <file path=ppt/slides/slide4.xml><?xml version="1.0" encoding="utf-8"?>
-<p:sld xmlns:p="http://schemas.openxmlformats.org/presentationml/2006/main">
+<p:sld xmlns:a="http://schemas.openxmlformats.org/drawingml/2006/main" xmlns:p="http://schemas.openxmlformats.org/presentationml/2006/main">
   <p:cSld>
     <p:bg>
       <p:bgPr>
@@ -2833,52 +2991,52 @@
         <p:txBody>
           <a:bodyPr xmlns:a="http://schemas.openxmlformats.org/drawingml/2006/main"/>
           <a:lstStyle xmlns:a="http://schemas.openxmlformats.org/drawingml/2006/main"/>
-          <a:p xmlns:a="http://schemas.openxmlformats.org/drawingml/2006/main">
-            <a:r>
-              <a:rPr lang="en-US" sz="1800">
+          <a:p>
+            <a:r>
+              <a:rPr lang="en-US" sz="1700">
                 <a:solidFill>
                   <a:srgbClr val="333333"/>
                 </a:solidFill>
                 <a:latin typeface="Calibri"/>
                 <a:ea typeface="Calibri"/>
               </a:rPr>
-              <a:t>Profesional usia 22-35, bekerja di non-tech (admin, marketing, guru, operasional)</a:t>
-            </a:r>
-          </a:p>
-          <a:p xmlns:a="http://schemas.openxmlformats.org/drawingml/2006/main">
-            <a:r>
-              <a:rPr lang="en-US" sz="1800">
+              <a:t>→  Profesional usia 22–35, bekerja di non-tech (admin, marketing, guru)</a:t>
+            </a:r>
+          </a:p>
+          <a:p>
+            <a:r>
+              <a:rPr lang="en-US" sz="1700">
                 <a:solidFill>
                   <a:srgbClr val="333333"/>
                 </a:solidFill>
                 <a:latin typeface="Calibri"/>
                 <a:ea typeface="Calibri"/>
               </a:rPr>
-              <a:t>Ingin pindah ke tech role: data analyst, backend dev, ML engineer dalam 1-6 bulan</a:t>
-            </a:r>
-          </a:p>
-          <a:p xmlns:a="http://schemas.openxmlformats.org/drawingml/2006/main">
-            <a:r>
-              <a:rPr lang="en-US" sz="1800">
+              <a:t>→  Target: data analyst, backend dev, ML engineer — dalam 1–6 bulan</a:t>
+            </a:r>
+          </a:p>
+          <a:p>
+            <a:r>
+              <a:rPr lang="en-US" sz="1700">
                 <a:solidFill>
                   <a:srgbClr val="333333"/>
                 </a:solidFill>
                 <a:latin typeface="Calibri"/>
                 <a:ea typeface="Calibri"/>
               </a:rPr>
-              <a:t>Belajar mandiri, waktu terbatas, bahasa Indonesia, tidak mau/mampu bayar bootcamp mahal</a:t>
-            </a:r>
-          </a:p>
-          <a:p xmlns:a="http://schemas.openxmlformats.org/drawingml/2006/main">
-            <a:r>
-              <a:rPr lang="en-US" sz="1800">
+              <a:t>→  Belajar mandiri, waktu terbatas, Bahasa Indonesia, anggaran terbatas</a:t>
+            </a:r>
+          </a:p>
+          <a:p>
+            <a:r>
+              <a:rPr lang="en-US" sz="1700">
                 <a:solidFill>
                   <a:srgbClr val="333333"/>
                 </a:solidFill>
                 <a:latin typeface="Calibri"/>
                 <a:ea typeface="Calibri"/>
               </a:rPr>
-              <a:t>Job-to-be-done: 'Saya mau jadi data analyst 3 bulan -- sudah mulai tapi tidak tahu harus ngapain selanjutnya'</a:t>
+              <a:t>→  JTBD: "Saya mau jadi data analyst dalam 3 bulan — sudah mulai tapi tidak tahu harus ngapain selanjutnya"</a:t>
             </a:r>
           </a:p>
         </p:txBody>
@@ -2902,28 +3060,28 @@
         <p:txBody>
           <a:bodyPr xmlns:a="http://schemas.openxmlformats.org/drawingml/2006/main"/>
           <a:lstStyle xmlns:a="http://schemas.openxmlformats.org/drawingml/2006/main"/>
-          <a:p xmlns:a="http://schemas.openxmlformats.org/drawingml/2006/main">
-            <a:r>
-              <a:rPr lang="en-US" sz="1600">
+          <a:p>
+            <a:r>
+              <a:rPr lang="en-US" sz="1500">
                 <a:solidFill>
                   <a:srgbClr val="555555"/>
                 </a:solidFill>
                 <a:latin typeface="Calibri"/>
                 <a:ea typeface="Calibri"/>
               </a:rPr>
-              <a:t>Pengguna Sekunder: Tech worker yang ingin naik level / pivot domain</a:t>
-            </a:r>
-          </a:p>
-          <a:p xmlns:a="http://schemas.openxmlformats.org/drawingml/2006/main">
-            <a:r>
-              <a:rPr lang="en-US" sz="1600">
+              <a:t>Sekunder: Tech worker naik level / pivot domain</a:t>
+            </a:r>
+          </a:p>
+          <a:p>
+            <a:r>
+              <a:rPr lang="en-US" sz="1500">
                 <a:solidFill>
                   <a:srgbClr val="555555"/>
                 </a:solidFill>
                 <a:latin typeface="Calibri"/>
                 <a:ea typeface="Calibri"/>
               </a:rPr>
-              <a:t>Pengguna B2B (roadmap): bootcamp, kampus, program reskilling Komdigi</a:t>
+              <a:t>B2B (roadmap): bootcamp, kampus, program reskilling Komdigi</a:t>
             </a:r>
           </a:p>
         </p:txBody>
@@ -2949,16 +3107,43 @@
           <a:lstStyle xmlns:a="http://schemas.openxmlformats.org/drawingml/2006/main"/>
           <a:p xmlns:a="http://schemas.openxmlformats.org/drawingml/2006/main">
             <a:r>
-              <a:rPr lang="en-US" sz="1400">
-                <a:solidFill>
-                  <a:srgbClr val="888888"/>
-                </a:solidFill>
-                <a:latin typeface="Calibri"/>
-                <a:ea typeface="Calibri"/>
-              </a:rPr>
-              <a:t>OECD (2024): kesenjangan tech skills vs output pendidikan tradisional terus melebar -- reskilling mandiri adalah solusi utama, tapi minim dukungan adaptif.</a:t>
-            </a:r>
-          </a:p>
+              <a:rPr lang="en-US" sz="1300">
+                <a:solidFill>
+                  <a:srgbClr val="777777"/>
+                </a:solidFill>
+                <a:latin typeface="Calibri"/>
+                <a:ea typeface="Calibri"/>
+              </a:rPr>
+              <a:t>📊  OECD (2024): kesenjangan tech skills vs output pendidikan tradisional terus melebar — reskilling mandiri adalah solusi utama, tapi minim dukungan adaptif.</a:t>
+            </a:r>
+          </a:p>
+        </p:txBody>
+      </p:sp>
+      <p:sp>
+        <p:nvSpPr>
+          <p:cNvPr id="100062" name="TextBox 7"/>
+          <p:cNvSpPr/>
+          <p:nvPr/>
+        </p:nvSpPr>
+        <p:spPr>
+          <a:xfrm>
+            <a:off x="540000" y="1116000"/>
+            <a:ext cx="1260000" cy="21600"/>
+          </a:xfrm>
+          <a:prstGeom prst="rect">
+            <a:avLst/>
+          </a:prstGeom>
+          <a:solidFill>
+            <a:srgbClr val="1E2761"/>
+          </a:solidFill>
+          <a:ln>
+            <a:noFill/>
+          </a:ln>
+        </p:spPr>
+        <p:txBody>
+          <a:bodyPr/>
+          <a:lstStyle/>
+          <a:p/>
         </p:txBody>
       </p:sp>
     </p:spTree>
@@ -2967,7 +3152,7 @@
 </file>
 
 <file path=ppt/slides/slide5.xml><?xml version="1.0" encoding="utf-8"?>
-<p:sld xmlns:p="http://schemas.openxmlformats.org/presentationml/2006/main">
+<p:sld xmlns:a="http://schemas.openxmlformats.org/drawingml/2006/main" xmlns:p="http://schemas.openxmlformats.org/presentationml/2006/main">
   <p:cSld>
     <p:bg>
       <p:bgPr>
@@ -3070,14 +3255,14 @@
           <a:lstStyle xmlns:a="http://schemas.openxmlformats.org/drawingml/2006/main"/>
           <a:p xmlns:a="http://schemas.openxmlformats.org/drawingml/2006/main">
             <a:r>
-              <a:rPr lang="en-US" sz="1600">
-                <a:solidFill>
-                  <a:srgbClr val="A8C8FF"/>
-                </a:solidFill>
-                <a:latin typeface="Calibri"/>
-                <a:ea typeface="Calibri"/>
-              </a:rPr>
-              <a:t>Alur MVP (terverifikasi end-to-end):</a:t>
+              <a:rPr lang="en-US" sz="1600" b="1">
+                <a:solidFill>
+                  <a:srgbClr val="7DFFB0"/>
+                </a:solidFill>
+                <a:latin typeface="Calibri"/>
+                <a:ea typeface="Calibri"/>
+              </a:rPr>
+              <a:t>✅  Alur MVP — terverifikasi end-to-end:</a:t>
             </a:r>
           </a:p>
         </p:txBody>
@@ -3103,14 +3288,14 @@
           <a:lstStyle xmlns:a="http://schemas.openxmlformats.org/drawingml/2006/main"/>
           <a:p xmlns:a="http://schemas.openxmlformats.org/drawingml/2006/main">
             <a:r>
-              <a:rPr lang="en-US" sz="1800" b="1">
+              <a:rPr lang="en-US" sz="1700" b="1">
                 <a:solidFill>
                   <a:srgbClr val="FFFFFF"/>
                 </a:solidFill>
                 <a:latin typeface="Calibri"/>
                 <a:ea typeface="Calibri"/>
               </a:rPr>
-              <a:t>1. Pengguna ketik goal karier di Web App  --&gt;  2. Web App memanggil MCP tool  --&gt;  3. Langflow menjalankan agent flow  --&gt;  4. LLM menyusun roadmap JSON  --&gt;  5. Web App tampilkan roadmap mingguan</a:t>
+              <a:t>Web App  →  MCP tool  →  Langflow agent flow  →  LLM  →  Roadmap Mingguan</a:t>
             </a:r>
           </a:p>
         </p:txBody>
@@ -3134,9 +3319,9 @@
         <p:txBody>
           <a:bodyPr xmlns:a="http://schemas.openxmlformats.org/drawingml/2006/main"/>
           <a:lstStyle xmlns:a="http://schemas.openxmlformats.org/drawingml/2006/main"/>
-          <a:p xmlns:a="http://schemas.openxmlformats.org/drawingml/2006/main">
-            <a:r>
-              <a:rPr lang="en-US" sz="1800">
+          <a:p>
+            <a:r>
+              <a:rPr lang="en-US" sz="1700">
                 <a:solidFill>
                   <a:srgbClr val="C8DCFF"/>
                 </a:solidFill>
@@ -3146,9 +3331,9 @@
               <a:t>Stack integrasi:</a:t>
             </a:r>
           </a:p>
-          <a:p xmlns:a="http://schemas.openxmlformats.org/drawingml/2006/main">
-            <a:r>
-              <a:rPr lang="en-US" sz="1800">
+          <a:p>
+            <a:r>
+              <a:rPr lang="en-US" sz="1700">
                 <a:solidFill>
                   <a:srgbClr val="C8DCFF"/>
                 </a:solidFill>
@@ -3158,21 +3343,21 @@
               <a:t/>
             </a:r>
           </a:p>
-          <a:p xmlns:a="http://schemas.openxmlformats.org/drawingml/2006/main">
-            <a:r>
-              <a:rPr lang="en-US" sz="1800">
+          <a:p>
+            <a:r>
+              <a:rPr lang="en-US" sz="1700">
                 <a:solidFill>
                   <a:srgbClr val="C8DCFF"/>
                 </a:solidFill>
                 <a:latin typeface="Calibri"/>
                 <a:ea typeface="Calibri"/>
               </a:rPr>
-              <a:t>IBM Bob (harness pengembangan)  --&gt;  MCP (streamable HTTP)  --&gt;  Langflow flow engine  --&gt;  NaraRouter / longcat-2.5 (LLM)</a:t>
-            </a:r>
-          </a:p>
-          <a:p xmlns:a="http://schemas.openxmlformats.org/drawingml/2006/main">
-            <a:r>
-              <a:rPr lang="en-US" sz="1800">
+              <a:t>IBM Bob  →  MCP (streamable HTTP)  →  Langflow flow engine  →  NaraRouter / longcat-2.5</a:t>
+            </a:r>
+          </a:p>
+          <a:p>
+            <a:r>
+              <a:rPr lang="en-US" sz="1700">
                 <a:solidFill>
                   <a:srgbClr val="C8DCFF"/>
                 </a:solidFill>
@@ -3182,16 +3367,16 @@
               <a:t/>
             </a:r>
           </a:p>
-          <a:p xmlns:a="http://schemas.openxmlformats.org/drawingml/2006/main">
-            <a:r>
-              <a:rPr lang="en-US" sz="1800">
+          <a:p>
+            <a:r>
+              <a:rPr lang="en-US" sz="1700">
                 <a:solidFill>
                   <a:srgbClr val="C8DCFF"/>
                 </a:solidFill>
                 <a:latin typeface="Calibri"/>
                 <a:ea typeface="Calibri"/>
               </a:rPr>
-              <a:t>Kontrak MCP yang sama dipakai saat pengembangan (Bob) dan produksi (Web App backend) -- tanpa mengubah flow Langflow.</a:t>
+              <a:t>Kontrak MCP identik saat dev (Bob) dan produksi (Web App backend) — tanpa ubah flow Langflow.</a:t>
             </a:r>
           </a:p>
         </p:txBody>
@@ -3217,14 +3402,14 @@
           <a:lstStyle xmlns:a="http://schemas.openxmlformats.org/drawingml/2006/main"/>
           <a:p xmlns:a="http://schemas.openxmlformats.org/drawingml/2006/main">
             <a:r>
-              <a:rPr lang="en-US" sz="1600" b="1">
+              <a:rPr lang="en-US" sz="1500" b="1">
                 <a:solidFill>
                   <a:srgbClr val="7DFFB0"/>
                 </a:solidFill>
                 <a:latin typeface="Calibri"/>
                 <a:ea typeface="Calibri"/>
               </a:rPr>
-              <a:t>[VERIFIED] Goal Agent e2e: Bob --&gt; goal_decomposer MCP tool --&gt; JSON roadmap 12 minggu</a:t>
+              <a:t>✅  VERIFIED: Bob → goal_decomposer MCP tool → JSON roadmap 12 minggu</a:t>
             </a:r>
           </a:p>
         </p:txBody>
@@ -3235,7 +3420,7 @@
 </file>
 
 <file path=ppt/slides/slide6.xml><?xml version="1.0" encoding="utf-8"?>
-<p:sld xmlns:p="http://schemas.openxmlformats.org/presentationml/2006/main">
+<p:sld xmlns:a="http://schemas.openxmlformats.org/drawingml/2006/main" xmlns:p="http://schemas.openxmlformats.org/presentationml/2006/main">
   <p:cSld>
     <p:bg>
       <p:bgPr>
@@ -3359,67 +3544,67 @@
         <p:spPr>
           <a:xfrm xmlns:a="http://schemas.openxmlformats.org/drawingml/2006/main">
             <a:off x="540000" y="1512000"/>
-            <a:ext cx="10800000" cy="2340000"/>
-          </a:xfrm>
-          <a:prstGeom xmlns:a="http://schemas.openxmlformats.org/drawingml/2006/main" prst="rect">
-            <a:avLst/>
-          </a:prstGeom>
-          <a:noFill xmlns:a="http://schemas.openxmlformats.org/drawingml/2006/main"/>
-        </p:spPr>
-        <p:txBody>
-          <a:bodyPr xmlns:a="http://schemas.openxmlformats.org/drawingml/2006/main"/>
-          <a:lstStyle xmlns:a="http://schemas.openxmlformats.org/drawingml/2006/main"/>
-          <a:p xmlns:a="http://schemas.openxmlformats.org/drawingml/2006/main">
-            <a:r>
-              <a:rPr lang="en-US" sz="1800">
+            <a:ext cx="10800000" cy="2160000"/>
+          </a:xfrm>
+          <a:prstGeom xmlns:a="http://schemas.openxmlformats.org/drawingml/2006/main" prst="rect">
+            <a:avLst/>
+          </a:prstGeom>
+          <a:noFill xmlns:a="http://schemas.openxmlformats.org/drawingml/2006/main"/>
+        </p:spPr>
+        <p:txBody>
+          <a:bodyPr xmlns:a="http://schemas.openxmlformats.org/drawingml/2006/main"/>
+          <a:lstStyle xmlns:a="http://schemas.openxmlformats.org/drawingml/2006/main"/>
+          <a:p>
+            <a:r>
+              <a:rPr lang="en-US" sz="1700">
                 <a:solidFill>
                   <a:srgbClr val="333333"/>
                 </a:solidFill>
                 <a:latin typeface="Calibri"/>
                 <a:ea typeface="Calibri"/>
               </a:rPr>
-              <a:t>IBM Bob  --  AI agent harness pengembangan: build, test, verifikasi agent e2e</a:t>
-            </a:r>
-          </a:p>
-          <a:p xmlns:a="http://schemas.openxmlformats.org/drawingml/2006/main">
-            <a:r>
-              <a:rPr lang="en-US" sz="1800">
+              <a:t>IBM Bob  —  AI agent harness: build, test, verifikasi agent e2e</a:t>
+            </a:r>
+          </a:p>
+          <a:p>
+            <a:r>
+              <a:rPr lang="en-US" sz="1700">
                 <a:solidFill>
                   <a:srgbClr val="333333"/>
                 </a:solidFill>
                 <a:latin typeface="Calibri"/>
                 <a:ea typeface="Calibri"/>
               </a:rPr>
-              <a:t>IBM Langflow  --  Flow execution engine: setiap agent = 1 flow = 1 MCP tool</a:t>
-            </a:r>
-          </a:p>
-          <a:p xmlns:a="http://schemas.openxmlformats.org/drawingml/2006/main">
-            <a:r>
-              <a:rPr lang="en-US" sz="1800">
+              <a:t>IBM Langflow  —  Flow execution engine: setiap agent = 1 flow = 1 MCP tool</a:t>
+            </a:r>
+          </a:p>
+          <a:p>
+            <a:r>
+              <a:rPr lang="en-US" sz="1700">
                 <a:solidFill>
                   <a:srgbClr val="333333"/>
                 </a:solidFill>
                 <a:latin typeface="Calibri"/>
                 <a:ea typeface="Calibri"/>
               </a:rPr>
-              <a:t>MCP (Model Context Protocol)  --  Bridge antara pemanggil dan agent Langflow</a:t>
-            </a:r>
-          </a:p>
-          <a:p xmlns:a="http://schemas.openxmlformats.org/drawingml/2006/main">
-            <a:r>
-              <a:rPr lang="en-US" sz="1800">
+              <a:t>MCP (Model Context Protocol)  —  Bridge pemanggil ↔ agent Langflow</a:t>
+            </a:r>
+          </a:p>
+          <a:p>
+            <a:r>
+              <a:rPr lang="en-US" sz="1700">
                 <a:solidFill>
                   <a:srgbClr val="333333"/>
                 </a:solidFill>
                 <a:latin typeface="Calibri"/>
                 <a:ea typeface="Calibri"/>
               </a:rPr>
-              <a:t>NaraRouter / longcat-2.5  --  LLM backbone: reasoning + generation (temperature 0.3)</a:t>
-            </a:r>
-          </a:p>
-          <a:p xmlns:a="http://schemas.openxmlformats.org/drawingml/2006/main">
-            <a:r>
-              <a:rPr lang="en-US" sz="1800">
+              <a:t>NaraRouter / longcat-2.5  —  LLM backbone (temperature 0.3)</a:t>
+            </a:r>
+          </a:p>
+          <a:p>
+            <a:r>
+              <a:rPr lang="en-US" sz="1700">
                 <a:solidFill>
                   <a:srgbClr val="333333"/>
                 </a:solidFill>
@@ -3429,52 +3614,28 @@
               <a:t/>
             </a:r>
           </a:p>
-          <a:p xmlns:a="http://schemas.openxmlformats.org/drawingml/2006/main">
-            <a:r>
-              <a:rPr lang="en-US" sz="1800">
+          <a:p>
+            <a:r>
+              <a:rPr lang="en-US" sz="1700">
                 <a:solidFill>
                   <a:srgbClr val="333333"/>
                 </a:solidFill>
                 <a:latin typeface="Calibri"/>
                 <a:ea typeface="Calibri"/>
               </a:rPr>
-              <a:t>Arsitektur:</a:t>
-            </a:r>
-          </a:p>
-          <a:p xmlns:a="http://schemas.openxmlformats.org/drawingml/2006/main">
-            <a:r>
-              <a:rPr lang="en-US" sz="1800">
+              <a:t>Arsitektur:  Web App  →  [MCP streamable HTTP]  →  Langflow  →  LLM</a:t>
+            </a:r>
+          </a:p>
+          <a:p>
+            <a:r>
+              <a:rPr lang="en-US" sz="1700">
                 <a:solidFill>
                   <a:srgbClr val="333333"/>
                 </a:solidFill>
                 <a:latin typeface="Calibri"/>
                 <a:ea typeface="Calibri"/>
               </a:rPr>
-              <a:t>Web App Backend  --[MCP streamable HTTP]--&gt;  Langflow  --&gt;  LLM</a:t>
-            </a:r>
-          </a:p>
-          <a:p xmlns:a="http://schemas.openxmlformats.org/drawingml/2006/main">
-            <a:r>
-              <a:rPr lang="en-US" sz="1800">
-                <a:solidFill>
-                  <a:srgbClr val="333333"/>
-                </a:solidFill>
-                <a:latin typeface="Calibri"/>
-                <a:ea typeface="Calibri"/>
-              </a:rPr>
-              <a:t/>
-            </a:r>
-          </a:p>
-          <a:p xmlns:a="http://schemas.openxmlformats.org/drawingml/2006/main">
-            <a:r>
-              <a:rPr lang="en-US" sz="1800">
-                <a:solidFill>
-                  <a:srgbClr val="333333"/>
-                </a:solidFill>
-                <a:latin typeface="Calibri"/>
-                <a:ea typeface="Calibri"/>
-              </a:rPr>
-              <a:t>Setiap agent diekspos sebagai named MCP tool; pemanggil bisa diganti tanpa ubah flow.</a:t>
+              <a:t>Named MCP tool per agent — pemanggil bisa diganti tanpa ubah flow.</a:t>
             </a:r>
           </a:p>
         </p:txBody>
@@ -3487,89 +3648,83 @@
         </p:nvSpPr>
         <p:spPr>
           <a:xfrm xmlns:a="http://schemas.openxmlformats.org/drawingml/2006/main">
-            <a:off x="540000" y="3960000"/>
-            <a:ext cx="10800000" cy="1260000"/>
-          </a:xfrm>
-          <a:prstGeom xmlns:a="http://schemas.openxmlformats.org/drawingml/2006/main" prst="rect">
-            <a:avLst/>
-          </a:prstGeom>
-          <a:noFill xmlns:a="http://schemas.openxmlformats.org/drawingml/2006/main"/>
-        </p:spPr>
-        <p:txBody>
-          <a:bodyPr xmlns:a="http://schemas.openxmlformats.org/drawingml/2006/main"/>
-          <a:lstStyle xmlns:a="http://schemas.openxmlformats.org/drawingml/2006/main"/>
-          <a:p xmlns:a="http://schemas.openxmlformats.org/drawingml/2006/main">
-            <a:r>
-              <a:rPr lang="en-US" sz="1500">
-                <a:solidFill>
-                  <a:srgbClr val="555555"/>
-                </a:solidFill>
-                <a:latin typeface="Calibri"/>
-                <a:ea typeface="Calibri"/>
-              </a:rPr>
-              <a:t>Landasan riset desain AI:</a:t>
-            </a:r>
-          </a:p>
-          <a:p xmlns:a="http://schemas.openxmlformats.org/drawingml/2006/main">
-            <a:r>
-              <a:rPr lang="en-US" sz="1500">
-                <a:solidFill>
-                  <a:srgbClr val="555555"/>
-                </a:solidFill>
-                <a:latin typeface="Calibri"/>
-                <a:ea typeface="Calibri"/>
-              </a:rPr>
-              <a:t>GenMentor (FWCI 47.3) -- goal-to-skill mapping, multi-agent ITS</a:t>
-            </a:r>
-          </a:p>
-          <a:p xmlns:a="http://schemas.openxmlformats.org/drawingml/2006/main">
-            <a:r>
-              <a:rPr lang="en-US" sz="1500">
-                <a:solidFill>
-                  <a:srgbClr val="555555"/>
-                </a:solidFill>
-                <a:latin typeface="Calibri"/>
-                <a:ea typeface="Calibri"/>
-              </a:rPr>
-              <a:t>IntelliCode (FWCI 23.5) -- graduated hinting, centralized learner state</a:t>
-            </a:r>
-          </a:p>
-          <a:p xmlns:a="http://schemas.openxmlformats.org/drawingml/2006/main">
-            <a:r>
-              <a:rPr lang="en-US" sz="1500">
-                <a:solidFill>
-                  <a:srgbClr val="555555"/>
-                </a:solidFill>
-                <a:latin typeface="Calibri"/>
-                <a:ea typeface="Calibri"/>
-              </a:rPr>
-              <a:t>Feynman Bot (arXiv 2506.09055) -- 80%+ peserta lebih suka daripada membaca pasif</a:t>
-            </a:r>
-          </a:p>
-          <a:p xmlns:a="http://schemas.openxmlformats.org/drawingml/2006/main">
-            <a:r>
-              <a:rPr lang="en-US" sz="1500">
-                <a:solidFill>
-                  <a:srgbClr val="555555"/>
-                </a:solidFill>
-                <a:latin typeface="Calibri"/>
-                <a:ea typeface="Calibri"/>
-              </a:rPr>
-              <a:t>Zaidi et al. (arXiv 2004.11327) -- adaptive spaced repetition +15-20% retensi</a:t>
-            </a:r>
-          </a:p>
-          <a:p xmlns:a="http://schemas.openxmlformats.org/drawingml/2006/main">
-            <a:r>
-              <a:rPr lang="en-US" sz="1500">
-                <a:solidFill>
-                  <a:srgbClr val="555555"/>
-                </a:solidFill>
-                <a:latin typeface="Calibri"/>
-                <a:ea typeface="Calibri"/>
-              </a:rPr>
-              <a:t>BJET (dikutip 694x) -- guardrail anti-cognitive-offloading</a:t>
-            </a:r>
-          </a:p>
+            <a:off x="540000" y="3888000"/>
+            <a:ext cx="10800000" cy="540000"/>
+          </a:xfrm>
+          <a:prstGeom xmlns:a="http://schemas.openxmlformats.org/drawingml/2006/main" prst="rect">
+            <a:avLst/>
+          </a:prstGeom>
+          <a:noFill xmlns:a="http://schemas.openxmlformats.org/drawingml/2006/main"/>
+        </p:spPr>
+        <p:txBody>
+          <a:bodyPr xmlns:a="http://schemas.openxmlformats.org/drawingml/2006/main"/>
+          <a:lstStyle xmlns:a="http://schemas.openxmlformats.org/drawingml/2006/main"/>
+          <a:p>
+            <a:r>
+              <a:rPr lang="en-US" sz="1300">
+                <a:solidFill>
+                  <a:srgbClr val="666666"/>
+                </a:solidFill>
+                <a:latin typeface="Calibri"/>
+                <a:ea typeface="Calibri"/>
+              </a:rPr>
+              <a:t>📚  Landasan riset:  GenMentor (FWCI 47.3)  ·  IntelliCode (FWCI 23.5)  ·  Feynman Bot (arXiv 2506.09055)  ·  Zaidi et al. (arXiv 2004.11327)  ·  BJET (694× dikutip)</a:t>
+            </a:r>
+          </a:p>
+        </p:txBody>
+      </p:sp>
+      <p:sp>
+        <p:nvSpPr>
+          <p:cNvPr id="100063" name="TextBox 6"/>
+          <p:cNvSpPr/>
+          <p:nvPr/>
+        </p:nvSpPr>
+        <p:spPr>
+          <a:xfrm>
+            <a:off x="540000" y="1116000"/>
+            <a:ext cx="1260000" cy="21600"/>
+          </a:xfrm>
+          <a:prstGeom prst="rect">
+            <a:avLst/>
+          </a:prstGeom>
+          <a:solidFill>
+            <a:srgbClr val="1E2761"/>
+          </a:solidFill>
+          <a:ln>
+            <a:noFill/>
+          </a:ln>
+        </p:spPr>
+        <p:txBody>
+          <a:bodyPr/>
+          <a:lstStyle/>
+          <a:p/>
+        </p:txBody>
+      </p:sp>
+      <p:sp>
+        <p:nvSpPr>
+          <p:cNvPr id="100064" name="TextBox 7"/>
+          <p:cNvSpPr/>
+          <p:nvPr/>
+        </p:nvSpPr>
+        <p:spPr>
+          <a:xfrm>
+            <a:off x="540000" y="3780000"/>
+            <a:ext cx="10800000" cy="21600"/>
+          </a:xfrm>
+          <a:prstGeom prst="rect">
+            <a:avLst/>
+          </a:prstGeom>
+          <a:solidFill>
+            <a:srgbClr val="DDDDDD"/>
+          </a:solidFill>
+          <a:ln>
+            <a:noFill/>
+          </a:ln>
+        </p:spPr>
+        <p:txBody>
+          <a:bodyPr/>
+          <a:lstStyle/>
+          <a:p/>
         </p:txBody>
       </p:sp>
     </p:spTree>
@@ -3578,7 +3733,7 @@
 </file>
 
 <file path=ppt/slides/slide7.xml><?xml version="1.0" encoding="utf-8"?>
-<p:sld xmlns:p="http://schemas.openxmlformats.org/presentationml/2006/main">
+<p:sld xmlns:a="http://schemas.openxmlformats.org/drawingml/2006/main" xmlns:p="http://schemas.openxmlformats.org/presentationml/2006/main">
   <p:cSld>
     <p:bg>
       <p:bgPr>
@@ -3679,40 +3834,40 @@
         <p:txBody>
           <a:bodyPr xmlns:a="http://schemas.openxmlformats.org/drawingml/2006/main"/>
           <a:lstStyle xmlns:a="http://schemas.openxmlformats.org/drawingml/2006/main"/>
-          <a:p xmlns:a="http://schemas.openxmlformats.org/drawingml/2006/main">
-            <a:r>
-              <a:rPr lang="en-US" sz="1700">
+          <a:p>
+            <a:r>
+              <a:rPr lang="en-US" sz="1600">
                 <a:solidFill>
                   <a:srgbClr val="7DFFB0"/>
                 </a:solidFill>
                 <a:latin typeface="Calibri"/>
                 <a:ea typeface="Calibri"/>
               </a:rPr>
-              <a:t>[LIVE e2e] 1. Goal Decomposer Agent</a:t>
-            </a:r>
-          </a:p>
-          <a:p xmlns:a="http://schemas.openxmlformats.org/drawingml/2006/main">
-            <a:r>
-              <a:rPr lang="en-US" sz="1700">
+              <a:t>✅  LIVE e2e — Goal Decomposer Agent</a:t>
+            </a:r>
+          </a:p>
+          <a:p>
+            <a:r>
+              <a:rPr lang="en-US" sz="1600">
                 <a:solidFill>
                   <a:srgbClr val="7DFFB0"/>
                 </a:solidFill>
                 <a:latin typeface="Calibri"/>
                 <a:ea typeface="Calibri"/>
               </a:rPr>
-              <a:t>Pengguna ketik goal karier -&gt; roadmap mingguan JSON terstruktur (deadline_weeks, milestones, first_action)</a:t>
-            </a:r>
-          </a:p>
-          <a:p xmlns:a="http://schemas.openxmlformats.org/drawingml/2006/main">
-            <a:r>
-              <a:rPr lang="en-US" sz="1700">
+              <a:t>→  Ketik goal karier → roadmap JSON mingguan (deadline_weeks, milestones, first_action)</a:t>
+            </a:r>
+          </a:p>
+          <a:p>
+            <a:r>
+              <a:rPr lang="en-US" sz="1600">
                 <a:solidFill>
                   <a:srgbClr val="7DFFB0"/>
                 </a:solidFill>
                 <a:latin typeface="Calibri"/>
                 <a:ea typeface="Calibri"/>
               </a:rPr>
-              <a:t>MCP tool: goal_decomposer | Verified: Bob -&gt; Langflow -&gt; roadmap 12 minggu</a:t>
+              <a:t>→  MCP tool: goal_decomposer  |  Verified: Bob → Langflow → roadmap 12 minggu</a:t>
             </a:r>
           </a:p>
         </p:txBody>
@@ -3736,33 +3891,33 @@
         <p:txBody>
           <a:bodyPr xmlns:a="http://schemas.openxmlformats.org/drawingml/2006/main"/>
           <a:lstStyle xmlns:a="http://schemas.openxmlformats.org/drawingml/2006/main"/>
-          <a:p xmlns:a="http://schemas.openxmlformats.org/drawingml/2006/main">
-            <a:r>
-              <a:rPr lang="en-US" sz="1700">
+          <a:p>
+            <a:r>
+              <a:rPr lang="en-US" sz="1600">
                 <a:solidFill>
                   <a:srgbClr val="C8DCFF"/>
                 </a:solidFill>
                 <a:latin typeface="Calibri"/>
                 <a:ea typeface="Calibri"/>
               </a:rPr>
-              <a:t>[Dev] 2. Tutor Agent (Feynman)</a:t>
-            </a:r>
-          </a:p>
-          <a:p xmlns:a="http://schemas.openxmlformats.org/drawingml/2006/main">
-            <a:r>
-              <a:rPr lang="en-US" sz="1700">
+              <a:t>🔧  Dev — Tutor Agent (Feynman)</a:t>
+            </a:r>
+          </a:p>
+          <a:p>
+            <a:r>
+              <a:rPr lang="en-US" sz="1600">
                 <a:solidFill>
                   <a:srgbClr val="C8DCFF"/>
                 </a:solidFill>
                 <a:latin typeface="Calibri"/>
                 <a:ea typeface="Calibri"/>
               </a:rPr>
-              <a:t>Menjelaskan konsep dengan probing questions -- AI tidak menjawab langsung, memancing refleksi</a:t>
-            </a:r>
-          </a:p>
-          <a:p xmlns:a="http://schemas.openxmlformats.org/drawingml/2006/main">
-            <a:r>
-              <a:rPr lang="en-US" sz="1700">
+              <a:t>→  Probing questions: AI tidak menjawab langsung, memancing refleksi</a:t>
+            </a:r>
+          </a:p>
+          <a:p>
+            <a:r>
+              <a:rPr lang="en-US" sz="1600">
                 <a:solidFill>
                   <a:srgbClr val="C8DCFF"/>
                 </a:solidFill>
@@ -3772,28 +3927,28 @@
               <a:t/>
             </a:r>
           </a:p>
-          <a:p xmlns:a="http://schemas.openxmlformats.org/drawingml/2006/main">
-            <a:r>
-              <a:rPr lang="en-US" sz="1700">
+          <a:p>
+            <a:r>
+              <a:rPr lang="en-US" sz="1600">
                 <a:solidFill>
                   <a:srgbClr val="C8DCFF"/>
                 </a:solidFill>
                 <a:latin typeface="Calibri"/>
                 <a:ea typeface="Calibri"/>
               </a:rPr>
-              <a:t>[Dev] 3. Assessment Agent (Graduated Hinting)</a:t>
-            </a:r>
-          </a:p>
-          <a:p xmlns:a="http://schemas.openxmlformats.org/drawingml/2006/main">
-            <a:r>
-              <a:rPr lang="en-US" sz="1700">
+              <a:t>🔧  Dev — Assessment Agent (Graduated Hinting)</a:t>
+            </a:r>
+          </a:p>
+          <a:p>
+            <a:r>
+              <a:rPr lang="en-US" sz="1600">
                 <a:solidFill>
                   <a:srgbClr val="C8DCFF"/>
                 </a:solidFill>
                 <a:latin typeface="Calibri"/>
                 <a:ea typeface="Calibri"/>
               </a:rPr>
-              <a:t>Kuis adaptif; bila salah, petunjuk terkecil lebih dulu -- bukan jawaban langsung (IntelliCode, FWCI 23.5)</a:t>
+              <a:t>→  Kuis adaptif; hint terkecil dulu bila salah (IntelliCode, FWCI 23.5)</a:t>
             </a:r>
           </a:p>
         </p:txBody>
@@ -3817,33 +3972,33 @@
         <p:txBody>
           <a:bodyPr xmlns:a="http://schemas.openxmlformats.org/drawingml/2006/main"/>
           <a:lstStyle xmlns:a="http://schemas.openxmlformats.org/drawingml/2006/main"/>
-          <a:p xmlns:a="http://schemas.openxmlformats.org/drawingml/2006/main">
-            <a:r>
-              <a:rPr lang="en-US" sz="1700">
+          <a:p>
+            <a:r>
+              <a:rPr lang="en-US" sz="1600">
                 <a:solidFill>
                   <a:srgbClr val="C8DCFF"/>
                 </a:solidFill>
                 <a:latin typeface="Calibri"/>
                 <a:ea typeface="Calibri"/>
               </a:rPr>
-              <a:t>[Dev] 4. Progress Agent (Spaced Repetition)</a:t>
-            </a:r>
-          </a:p>
-          <a:p xmlns:a="http://schemas.openxmlformats.org/drawingml/2006/main">
-            <a:r>
-              <a:rPr lang="en-US" sz="1700">
+              <a:t>🔧  Dev — Progress Agent (Spaced Repetition)</a:t>
+            </a:r>
+          </a:p>
+          <a:p>
+            <a:r>
+              <a:rPr lang="en-US" sz="1600">
                 <a:solidFill>
                   <a:srgbClr val="C8DCFF"/>
                 </a:solidFill>
                 <a:latin typeface="Calibri"/>
                 <a:ea typeface="Calibri"/>
               </a:rPr>
-              <a:t>Menjadwalkan review berbasis forgetting curve individual -- +15-20% retensi (Zaidi et al.)</a:t>
-            </a:r>
-          </a:p>
-          <a:p xmlns:a="http://schemas.openxmlformats.org/drawingml/2006/main">
-            <a:r>
-              <a:rPr lang="en-US" sz="1700">
+              <a:t>→  Jadwal review berbasis forgetting curve individual — +15–20% retensi (Zaidi et al.)</a:t>
+            </a:r>
+          </a:p>
+          <a:p>
+            <a:r>
+              <a:rPr lang="en-US" sz="1600">
                 <a:solidFill>
                   <a:srgbClr val="C8DCFF"/>
                 </a:solidFill>
@@ -3853,28 +4008,28 @@
               <a:t/>
             </a:r>
           </a:p>
-          <a:p xmlns:a="http://schemas.openxmlformats.org/drawingml/2006/main">
-            <a:r>
-              <a:rPr lang="en-US" sz="1700">
+          <a:p>
+            <a:r>
+              <a:rPr lang="en-US" sz="1600">
                 <a:solidFill>
                   <a:srgbClr val="C8DCFF"/>
                 </a:solidFill>
                 <a:latin typeface="Calibri"/>
                 <a:ea typeface="Calibri"/>
               </a:rPr>
-              <a:t>[Dev] 5. Motivator &amp; Wellbeing Agent</a:t>
-            </a:r>
-          </a:p>
-          <a:p xmlns:a="http://schemas.openxmlformats.org/drawingml/2006/main">
-            <a:r>
-              <a:rPr lang="en-US" sz="1700">
+              <a:t>🔧  Dev — Motivator &amp; Wellbeing Agent</a:t>
+            </a:r>
+          </a:p>
+          <a:p>
+            <a:r>
+              <a:rPr lang="en-US" sz="1600">
                 <a:solidFill>
                   <a:srgbClr val="C8DCFF"/>
                 </a:solidFill>
                 <a:latin typeface="Calibri"/>
                 <a:ea typeface="Calibri"/>
               </a:rPr>
-              <a:t>Nudge kontekstual + cek burnout berkala -- mencegah putus belajar di tengah jalan</a:t>
+              <a:t>→  Nudge kontekstual + cek burnout berkala</a:t>
             </a:r>
           </a:p>
         </p:txBody>
@@ -4268,14 +4423,14 @@
           <a:lstStyle xmlns:a="http://schemas.openxmlformats.org/drawingml/2006/main"/>
           <a:p xmlns:a="http://schemas.openxmlformats.org/drawingml/2006/main">
             <a:r>
-              <a:rPr lang="en-US" sz="1800" b="1">
+              <a:rPr lang="en-US" sz="1700" b="1">
                 <a:solidFill>
                   <a:srgbClr val="7DFFB0"/>
                 </a:solidFill>
                 <a:latin typeface="Calibri"/>
                 <a:ea typeface="Calibri"/>
               </a:rPr>
-              <a:t>North Star: Career Goal Progress Rate &gt;= 15%/minggu per pengguna aktif</a:t>
+              <a:t>⭐  North Star: Career Goal Progress Rate ≥ 15%/minggu per pengguna aktif</a:t>
             </a:r>
           </a:p>
         </p:txBody>
@@ -4299,21 +4454,21 @@
         <p:txBody>
           <a:bodyPr xmlns:a="http://schemas.openxmlformats.org/drawingml/2006/main"/>
           <a:lstStyle xmlns:a="http://schemas.openxmlformats.org/drawingml/2006/main"/>
-          <a:p xmlns:a="http://schemas.openxmlformats.org/drawingml/2006/main">
-            <a:r>
-              <a:rPr lang="en-US" sz="1800">
+          <a:p>
+            <a:r>
+              <a:rPr lang="en-US" sz="1600">
                 <a:solidFill>
                   <a:srgbClr val="FFFFFF"/>
                 </a:solidFill>
                 <a:latin typeface="Calibri"/>
                 <a:ea typeface="Calibri"/>
               </a:rPr>
-              <a:t>Roadmap personal: dari 2-4 jam riset mandiri menjadi kurang dari 1 menit -- terbukti pada demo e2e</a:t>
-            </a:r>
-          </a:p>
-          <a:p xmlns:a="http://schemas.openxmlformats.org/drawingml/2006/main">
-            <a:r>
-              <a:rPr lang="en-US" sz="1800">
+              <a:t>⚡  Roadmap personal: 2–4 jam riset mandiri → &lt; 1 menit — terbukti demo e2e</a:t>
+            </a:r>
+          </a:p>
+          <a:p>
+            <a:r>
+              <a:rPr lang="en-US" sz="1600">
                 <a:solidFill>
                   <a:srgbClr val="FFFFFF"/>
                 </a:solidFill>
@@ -4323,21 +4478,21 @@
               <a:t/>
             </a:r>
           </a:p>
-          <a:p xmlns:a="http://schemas.openxmlformats.org/drawingml/2006/main">
-            <a:r>
-              <a:rPr lang="en-US" sz="1800">
+          <a:p>
+            <a:r>
+              <a:rPr lang="en-US" sz="1600">
                 <a:solidFill>
                   <a:srgbClr val="FFFFFF"/>
                 </a:solidFill>
                 <a:latin typeface="Calibri"/>
                 <a:ea typeface="Calibri"/>
               </a:rPr>
-              <a:t>Retensi belajar: +15-20% vs jadwal spaced repetition tetap (Zaidi et al., arXiv 2004.11327)</a:t>
-            </a:r>
-          </a:p>
-          <a:p xmlns:a="http://schemas.openxmlformats.org/drawingml/2006/main">
-            <a:r>
-              <a:rPr lang="en-US" sz="1800">
+              <a:t>📈  Retensi belajar: +15–20% vs spaced repetition tetap (Zaidi et al., arXiv 2004.11327)</a:t>
+            </a:r>
+          </a:p>
+          <a:p>
+            <a:r>
+              <a:rPr lang="en-US" sz="1600">
                 <a:solidFill>
                   <a:srgbClr val="FFFFFF"/>
                 </a:solidFill>
@@ -4347,21 +4502,21 @@
               <a:t/>
             </a:r>
           </a:p>
-          <a:p xmlns:a="http://schemas.openxmlformats.org/drawingml/2006/main">
-            <a:r>
-              <a:rPr lang="en-US" sz="1800">
+          <a:p>
+            <a:r>
+              <a:rPr lang="en-US" sz="1600">
                 <a:solidFill>
                   <a:srgbClr val="FFFFFF"/>
                 </a:solidFill>
                 <a:latin typeface="Calibri"/>
                 <a:ea typeface="Calibri"/>
               </a:rPr>
-              <a:t>Target jangkauan: 1.000 pengguna/bulan pada 6 bulan pertama setelah rilis</a:t>
-            </a:r>
-          </a:p>
-          <a:p xmlns:a="http://schemas.openxmlformats.org/drawingml/2006/main">
-            <a:r>
-              <a:rPr lang="en-US" sz="1800">
+              <a:t>🎯  Target: 1.000 pengguna/bulan pada bulan ke-6 setelah rilis</a:t>
+            </a:r>
+          </a:p>
+          <a:p>
+            <a:r>
+              <a:rPr lang="en-US" sz="1600">
                 <a:solidFill>
                   <a:srgbClr val="FFFFFF"/>
                 </a:solidFill>
@@ -4371,21 +4526,21 @@
               <a:t/>
             </a:r>
           </a:p>
-          <a:p xmlns:a="http://schemas.openxmlformats.org/drawingml/2006/main">
-            <a:r>
-              <a:rPr lang="en-US" sz="1800">
+          <a:p>
+            <a:r>
+              <a:rPr lang="en-US" sz="1600">
                 <a:solidFill>
                   <a:srgbClr val="FFFFFF"/>
                 </a:solidFill>
                 <a:latin typeface="Calibri"/>
                 <a:ea typeface="Calibri"/>
               </a:rPr>
-              <a:t>Meta-analisis intervensi AI pada self-regulated learning: g = 1.613 (32 studi, Frontiers in Education 2025)</a:t>
-            </a:r>
-          </a:p>
-          <a:p xmlns:a="http://schemas.openxmlformats.org/drawingml/2006/main">
-            <a:r>
-              <a:rPr lang="en-US" sz="1800">
+              <a:t>🔬  Meta-analisis AI pada self-regulated learning: g = 1.613 (32 studi, Frontiers in Education 2025)</a:t>
+            </a:r>
+          </a:p>
+          <a:p>
+            <a:r>
+              <a:rPr lang="en-US" sz="1600">
                 <a:solidFill>
                   <a:srgbClr val="FFFFFF"/>
                 </a:solidFill>
@@ -4395,16 +4550,16 @@
               <a:t/>
             </a:r>
           </a:p>
-          <a:p xmlns:a="http://schemas.openxmlformats.org/drawingml/2006/main">
-            <a:r>
-              <a:rPr lang="en-US" sz="1800">
+          <a:p>
+            <a:r>
+              <a:rPr lang="en-US" sz="1600">
                 <a:solidFill>
                   <a:srgbClr val="FFFFFF"/>
                 </a:solidFill>
                 <a:latin typeface="Calibri"/>
                 <a:ea typeface="Calibri"/>
               </a:rPr>
-              <a:t>Feynman Bot: 80%+ peserta lebih pilih daripada membaca pasif (arXiv 2506.09055)</a:t>
+              <a:t>💡  Feynman Bot: 80%+ peserta lebih pilih daripada membaca pasif (arXiv 2506.09055)</a:t>
             </a:r>
           </a:p>
         </p:txBody>
@@ -4418,124 +4573,67 @@
         <p:spPr>
           <a:xfrm xmlns:a="http://schemas.openxmlformats.org/drawingml/2006/main">
             <a:off x="540000" y="4140000"/>
-            <a:ext cx="10800000" cy="1080000"/>
-          </a:xfrm>
-          <a:prstGeom xmlns:a="http://schemas.openxmlformats.org/drawingml/2006/main" prst="rect">
-            <a:avLst/>
-          </a:prstGeom>
-          <a:noFill xmlns:a="http://schemas.openxmlformats.org/drawingml/2006/main"/>
-        </p:spPr>
-        <p:txBody>
-          <a:bodyPr xmlns:a="http://schemas.openxmlformats.org/drawingml/2006/main"/>
-          <a:lstStyle xmlns:a="http://schemas.openxmlformats.org/drawingml/2006/main"/>
-          <a:p>
-            <a:r>
-              <a:rPr lang="en-US" sz="1400">
-                <a:solidFill>
-                  <a:srgbClr val="A8C8FF"/>
-                </a:solidFill>
-                <a:latin typeface="Calibri"/>
-                <a:ea typeface="Calibri"/>
-              </a:rPr>
-              <a:t>Mengapa bukan yang lain?</a:t>
-            </a:r>
-          </a:p>
-          <a:p>
-            <a:r>
-              <a:rPr lang="en-US" sz="1400">
-                <a:solidFill>
-                  <a:srgbClr val="A8C8FF"/>
-                </a:solidFill>
-                <a:latin typeface="Calibri"/>
-                <a:ea typeface="Calibri"/>
-              </a:rPr>
-              <a:t>vs ChatGPT: oracle langsung jawab vs scaffold + guardrail anti-cognitive-offloading (BJET 694x)</a:t>
-            </a:r>
-          </a:p>
-          <a:p>
-            <a:r>
-              <a:rPr lang="en-US" sz="1400">
-                <a:solidFill>
-                  <a:srgbClr val="A8C8FF"/>
-                </a:solidFill>
-                <a:latin typeface="Calibri"/>
-                <a:ea typeface="Calibri"/>
-              </a:rPr>
-              <a:t>vs Dicoding: jalur kursus tetap vs roadmap personal goal-anchored (Dicoding 1,3 juta+ pengguna, tapi tidak adaptif)</a:t>
-            </a:r>
-          </a:p>
-          <a:p>
-            <a:r>
-              <a:rPr lang="en-US" sz="1400">
-                <a:solidFill>
-                  <a:srgbClr val="A8C8FF"/>
-                </a:solidFill>
-                <a:latin typeface="Calibri"/>
-                <a:ea typeface="Calibri"/>
-              </a:rPr>
-              <a:t>vs DataCamp: track data tetap, English-first, mahal vs adaptif + Bahasa Indonesia</a:t>
-            </a:r>
-          </a:p>
-          <a:p>
-            <a:r>
-              <a:rPr lang="en-US" sz="1400">
-                <a:solidFill>
-                  <a:srgbClr val="A8C8FF"/>
-                </a:solidFill>
-                <a:latin typeface="Calibri"/>
-                <a:ea typeface="Calibri"/>
-              </a:rPr>
-              <a:t>vs Boot.dev: backend-only + English-only; Boots AI sudah Socratic (closest philosopher) tapi tidak ada Bahasa Indonesia</a:t>
-            </a:r>
-          </a:p>
-          <a:p>
-            <a:r>
-              <a:rPr lang="en-US" sz="1400">
-                <a:solidFill>
-                  <a:srgbClr val="A8C8FF"/>
-                </a:solidFill>
-                <a:latin typeface="Calibri"/>
-                <a:ea typeface="Calibri"/>
-              </a:rPr>
-              <a:t>vs Bootcamp: jadwal mahal vs 24/7 AI adaptif</a:t>
-            </a:r>
-          </a:p>
-          <a:p>
-            <a:r>
-              <a:rPr lang="en-US" sz="1400">
-                <a:solidFill>
-                  <a:srgbClr val="A8C8FF"/>
-                </a:solidFill>
-                <a:latin typeface="Calibri"/>
-                <a:ea typeface="Calibri"/>
-              </a:rPr>
-              <a:t/>
-            </a:r>
-          </a:p>
-          <a:p>
-            <a:r>
-              <a:rPr lang="en-US" sz="1400">
-                <a:solidFill>
-                  <a:srgbClr val="A8C8FF"/>
-                </a:solidFill>
-                <a:latin typeface="Calibri"/>
-                <a:ea typeface="Calibri"/>
-              </a:rPr>
-              <a:t>Strategic framing: Serambi.ai = 'Learning OS' di atas Dicoding/DataCamp/Boot.dev</a:t>
-            </a:r>
-          </a:p>
-          <a:p>
-            <a:r>
-              <a:rPr lang="en-US" sz="1400">
-                <a:solidFill>
-                  <a:srgbClr val="A8C8FF"/>
-                </a:solidFill>
-                <a:latin typeface="Calibri"/>
-                <a:ea typeface="Calibri"/>
-              </a:rPr>
-              <a:t>Kuadran unclaimed: High Adaptivity x Bahasa Indonesia</a:t>
-            </a:r>
-          </a:p>
+            <a:ext cx="10800000" cy="900000"/>
+          </a:xfrm>
+          <a:prstGeom xmlns:a="http://schemas.openxmlformats.org/drawingml/2006/main" prst="rect">
+            <a:avLst/>
+          </a:prstGeom>
+          <a:noFill xmlns:a="http://schemas.openxmlformats.org/drawingml/2006/main"/>
+        </p:spPr>
+        <p:txBody>
+          <a:bodyPr xmlns:a="http://schemas.openxmlformats.org/drawingml/2006/main"/>
+          <a:lstStyle xmlns:a="http://schemas.openxmlformats.org/drawingml/2006/main"/>
+          <a:p>
+            <a:r>
+              <a:rPr lang="en-US" sz="1200">
+                <a:solidFill>
+                  <a:srgbClr val="8AAADD"/>
+                </a:solidFill>
+                <a:latin typeface="Calibri"/>
+                <a:ea typeface="Calibri"/>
+              </a:rPr>
+              <a:t>Kuadran unclaimed: High Adaptivity × Bahasa Indonesia  —  Serambi.ai = 'Learning OS'</a:t>
+            </a:r>
+          </a:p>
+          <a:p>
+            <a:r>
+              <a:rPr lang="en-US" sz="1200">
+                <a:solidFill>
+                  <a:srgbClr val="8AAADD"/>
+                </a:solidFill>
+                <a:latin typeface="Calibri"/>
+                <a:ea typeface="Calibri"/>
+              </a:rPr>
+              <a:t>vs ChatGPT: oracle langsung jawab  ·  vs Dicoding: kursus tetap (1,3 juta+ user, tapi tidak adaptif)  ·  vs DataCamp: English-first, mahal  ·  vs Boot.dev: backend-only + English  ·  vs Bootcamp: jadwal mahal</a:t>
+            </a:r>
+          </a:p>
+        </p:txBody>
+      </p:sp>
+      <p:sp>
+        <p:nvSpPr>
+          <p:cNvPr id="100065" name="TextBox 6"/>
+          <p:cNvSpPr/>
+          <p:nvPr/>
+        </p:nvSpPr>
+        <p:spPr>
+          <a:xfrm>
+            <a:off x="540000" y="4068000"/>
+            <a:ext cx="10800000" cy="21600"/>
+          </a:xfrm>
+          <a:prstGeom prst="rect">
+            <a:avLst/>
+          </a:prstGeom>
+          <a:solidFill>
+            <a:srgbClr val="4499BB"/>
+          </a:solidFill>
+          <a:ln>
+            <a:noFill/>
+          </a:ln>
+        </p:spPr>
+        <p:txBody>
+          <a:bodyPr/>
+          <a:lstStyle/>
+          <a:p/>
         </p:txBody>
       </p:sp>
     </p:spTree>

</xml_diff>